<commit_message>
Make deck v3 open in PowerPoint: remove mislabeled embedded fonts, use Arial
The source deck embedded three GUID-obfuscated TrueType fonts declared as application/x-fontdata;
PowerPoint rejects that mismatch while LibreOffice and the schema check accept it. The build now strips
the fonts, switches DM Sans and Space Grotesk to Arial, and drops the conflicting sldSz type. Three text
trims keep slides 8, 9 and 16 inside their cards with Arial metrics. Evidence in TEST_03.

Co-Authored-By: Claude Opus 5.5 <noreply@anthropic.com>
Claude-Session: https://claude.ai/code/session_016cGM8N4AP69rY41a4ajBjX
</commit_message>
<xml_diff>
--- a/deck/CFO_CoS_deck_v3.pptx
+++ b/deck/CFO_CoS_deck_v3.pptx
@@ -1,6 +1,6 @@
 
 <file path=ppt/presentation.xml><?xml version="1.0" encoding="utf-8"?>
-<ns0:presentation xmlns:ns0="http://schemas.openxmlformats.org/presentationml/2006/main" xmlns:ns1="http://schemas.openxmlformats.org/officeDocument/2006/relationships" xmlns:ns2="http://schemas.openxmlformats.org/drawingml/2006/main" saveSubsetFonts="1" autoCompressPictures="0" embedTrueTypeFonts="1">
+<ns0:presentation xmlns:ns0="http://schemas.openxmlformats.org/presentationml/2006/main" xmlns:ns1="http://schemas.openxmlformats.org/officeDocument/2006/relationships" xmlns:ns2="http://schemas.openxmlformats.org/drawingml/2006/main" autoCompressPictures="0">
   <ns0:sldMasterIdLst>
     <ns0:sldMasterId id="2147483648" ns1:id="rId1"/>
   </ns0:sldMasterIdLst>
@@ -28,19 +28,8 @@
     <ns0:sldId id="273" ns1:id="rId24"/>
     <ns0:sldId id="278" ns1:id="rId33"/>
   </ns0:sldIdLst>
-  <ns0:sldSz cx="12192000" cy="6858000" type="screen4x3"/>
+  <ns0:sldSz cx="12192000" cy="6858000"/>
   <ns0:notesSz cx="6858000" cy="9144000"/>
-  <ns0:embeddedFontLst>
-    <ns0:embeddedFont>
-      <ns0:font typeface="Space Grotesk"/>
-      <ns0:bold ns1:id="rIdFont27"/>
-    </ns0:embeddedFont>
-    <ns0:embeddedFont>
-      <ns0:font typeface="DM Sans"/>
-      <ns0:regular ns1:id="rIdFont29"/>
-      <ns0:bold ns1:id="rIdFont28"/>
-    </ns0:embeddedFont>
-  </ns0:embeddedFontLst>
   <ns0:defaultTextStyle>
     <ns2:defPPr>
       <ns2:defRPr lang="en-US"/>
@@ -283,7 +272,7 @@
                         <a:solidFill>
                           <a:srgbClr val="FFFFFF"/>
                         </a:solidFill>
-                        <a:latin typeface="DM Sans"/>
+                        <a:latin typeface="Arial"/>
                       </a:rPr>
                       <a:t>$60M</a:t>
                     </a:r>
@@ -310,7 +299,7 @@
                         <a:solidFill>
                           <a:srgbClr val="FFFFFF"/>
                         </a:solidFill>
-                        <a:latin typeface="DM Sans"/>
+                        <a:latin typeface="Arial"/>
                       </a:rPr>
                       <a:t>-$8M</a:t>
                     </a:r>
@@ -337,7 +326,7 @@
                         <a:solidFill>
                           <a:srgbClr val="FFFFFF"/>
                         </a:solidFill>
-                        <a:latin typeface="DM Sans"/>
+                        <a:latin typeface="Arial"/>
                       </a:rPr>
                       <a:t>-$12M</a:t>
                     </a:r>
@@ -364,7 +353,7 @@
                         <a:solidFill>
                           <a:srgbClr val="FFFFFF"/>
                         </a:solidFill>
-                        <a:latin typeface="DM Sans"/>
+                        <a:latin typeface="Arial"/>
                       </a:rPr>
                       <a:t>-$15M</a:t>
                     </a:r>
@@ -391,7 +380,7 @@
                         <a:solidFill>
                           <a:srgbClr val="FFFFFF"/>
                         </a:solidFill>
-                        <a:latin typeface="DM Sans"/>
+                        <a:latin typeface="Arial"/>
                       </a:rPr>
                       <a:t>$25M</a:t>
                     </a:r>
@@ -491,7 +480,7 @@
                 <a:solidFill>
                   <a:srgbClr val="11052C"/>
                 </a:solidFill>
-                <a:latin typeface="DM Sans"/>
+                <a:latin typeface="Arial"/>
               </a:defRPr>
             </a:pPr>
           </a:p>
@@ -5626,7 +5615,7 @@
                 <a:solidFill>
                   <a:srgbClr val="C084FC"/>
                 </a:solidFill>
-                <a:latin typeface="DM Sans"/>
+                <a:latin typeface="Arial"/>
               </a:rPr>
               <a:t>NU HOLDINGS LTD. // OFFICE OF THE CFO &amp; CORPORATE GOVERNANCE</a:t>
             </a:r>
@@ -5665,7 +5654,7 @@
                 <a:solidFill>
                   <a:srgbClr val="FFFFFF"/>
                 </a:solidFill>
-                <a:latin typeface="Space Grotesk"/>
+                <a:latin typeface="Arial"/>
               </a:rPr>
               <a:t>Chief of Staff to the CFO: a planning engine, a Board rhythm and an HQ charter</a:t>
             </a:r>
@@ -5700,7 +5689,7 @@
                 <a:solidFill>
                   <a:srgbClr val="E9D5FF"/>
                 </a:solidFill>
-                <a:latin typeface="DM Sans"/>
+                <a:latin typeface="Arial"/>
               </a:rPr>
               <a:t>Case resolution, 60 days into the role. Prepared by Cassio Modelli for the Nu panel, October 2026. Nu figures are from public Q2'26 filings; my assumptions are listed on slide 3.</a:t>
             </a:r>
@@ -5735,7 +5724,7 @@
                 <a:solidFill>
                   <a:srgbClr val="FFFFFF"/>
                 </a:solidFill>
-                <a:latin typeface="DM Sans"/>
+                <a:latin typeface="Arial"/>
               </a:rPr>
               <a:t>Four deliverables: (1) Planning and prioritization engine  (2) C-suite alignment and Board rhythm  (3) HQ execution roadmap  (4) How I lead</a:t>
             </a:r>
@@ -5770,7 +5759,7 @@
                 <a:solidFill>
                   <a:srgbClr val="C084FC"/>
                 </a:solidFill>
-                <a:latin typeface="DM Sans"/>
+                <a:latin typeface="Arial"/>
               </a:rPr>
               <a:t>PILLAR 1 // PLANNING</a:t>
             </a:r>
@@ -5805,7 +5794,7 @@
                 <a:solidFill>
                   <a:srgbClr val="FFFFFF"/>
                 </a:solidFill>
-                <a:latin typeface="Space Grotesk"/>
+                <a:latin typeface="Arial"/>
               </a:rPr>
               <a:t>$60M Asks vs. $25M Cap</a:t>
             </a:r>
@@ -5840,7 +5829,7 @@
                 <a:solidFill>
                   <a:srgbClr val="D8B4FE"/>
                 </a:solidFill>
-                <a:latin typeface="DM Sans"/>
+                <a:latin typeface="Arial"/>
               </a:rPr>
               <a:t>Bring planning in-house and answer $60M of growth asks inside a $25M cost cap.</a:t>
             </a:r>
@@ -5875,7 +5864,7 @@
                 <a:solidFill>
                   <a:srgbClr val="C084FC"/>
                 </a:solidFill>
-                <a:latin typeface="DM Sans"/>
+                <a:latin typeface="Arial"/>
               </a:rPr>
               <a:t>PILLAR 2 // GOVERNANCE</a:t>
             </a:r>
@@ -5910,7 +5899,7 @@
                 <a:solidFill>
                   <a:srgbClr val="FFFFFF"/>
                 </a:solidFill>
-                <a:latin typeface="Space Grotesk"/>
+                <a:latin typeface="Arial"/>
               </a:rPr>
               <a:t>4-Week Board Crunch</a:t>
             </a:r>
@@ -5945,7 +5934,7 @@
                 <a:solidFill>
                   <a:srgbClr val="D8B4FE"/>
                 </a:solidFill>
-                <a:latin typeface="DM Sans"/>
+                <a:latin typeface="Arial"/>
               </a:rPr>
               <a:t>Settle two opposing capital views and get the Board book out on time.</a:t>
             </a:r>
@@ -5980,7 +5969,7 @@
                 <a:solidFill>
                   <a:srgbClr val="C084FC"/>
                 </a:solidFill>
-                <a:latin typeface="DM Sans"/>
+                <a:latin typeface="Arial"/>
               </a:rPr>
               <a:t>PILLAR 3 // SPECIAL PROJECT</a:t>
             </a:r>
@@ -6015,7 +6004,7 @@
                 <a:solidFill>
                   <a:srgbClr val="FFFFFF"/>
                 </a:solidFill>
-                <a:latin typeface="Space Grotesk"/>
+                <a:latin typeface="Arial"/>
               </a:rPr>
               <a:t>New Regional HQ Deal</a:t>
             </a:r>
@@ -6050,7 +6039,7 @@
                 <a:solidFill>
                   <a:srgbClr val="D8B4FE"/>
                 </a:solidFill>
-                <a:latin typeface="DM Sans"/>
+                <a:latin typeface="Arial"/>
               </a:rPr>
               <a:t>Lead legal, tax and campus terms across jurisdictions without line authority.</a:t>
             </a:r>
@@ -6085,7 +6074,7 @@
                 <a:solidFill>
                   <a:srgbClr val="C084FC"/>
                 </a:solidFill>
-                <a:latin typeface="DM Sans"/>
+                <a:latin typeface="Arial"/>
               </a:rPr>
               <a:t>1</a:t>
             </a:r>
@@ -6336,7 +6325,7 @@
                 <a:solidFill>
                   <a:srgbClr val="820AD1"/>
                 </a:solidFill>
-                <a:latin typeface="DM Sans"/>
+                <a:latin typeface="Arial"/>
               </a:rPr>
               <a:t>14 // DELIVERABLE 3: THE HQ CHARTER</a:t>
             </a:r>
@@ -6375,7 +6364,7 @@
                 <a:solidFill>
                   <a:srgbClr val="11052C"/>
                 </a:solidFill>
-                <a:latin typeface="Space Grotesk"/>
+                <a:latin typeface="Arial"/>
               </a:rPr>
               <a:t>HQ charter: four gates in 120 days from signature, each with an owner, an exit test and a stop condition</a:t>
             </a:r>
@@ -6410,7 +6399,7 @@
                 <a:solidFill>
                   <a:srgbClr val="6B5B82"/>
                 </a:solidFill>
-                <a:latin typeface="DM Sans"/>
+                <a:latin typeface="Arial"/>
               </a:rPr>
               <a:t>Sources: [1] OECD GloBE Model Rules, Art. 5.3 and the Art. 9.2 transitional rates for 2026. [2] Location-incentive practice (e.g. Deloitte, Site Selection) is directional. [3] Cross-border director-liability guidance (e.g. NACD, Baker McKenzie) is directional. No savings figure is claimed until a site is chosen.</a:t>
             </a:r>
@@ -6445,7 +6434,7 @@
                 <a:solidFill>
                   <a:srgbClr val="FFFFFF"/>
                 </a:solidFill>
-                <a:latin typeface="DM Sans"/>
+                <a:latin typeface="Arial"/>
               </a:rPr>
               <a:t>Leading it as an interim across non-finance teams: </a:t>
             </a:r>
@@ -6454,7 +6443,7 @@
                 <a:solidFill>
                   <a:srgbClr val="FFFFFF"/>
                 </a:solidFill>
-                <a:latin typeface="DM Sans"/>
+                <a:latin typeface="Arial"/>
               </a:rPr>
               <a:t>one weekly pod (Legal, Tax, People, Workplace), one decision log, 48-hour escalation to the CFO, and a five-item risk register reviewed at every gate: tax residence, clawback, officer liability, site politics, key-person dependence on me. Jurisdiction is open (A8).</a:t>
             </a:r>
@@ -6489,7 +6478,7 @@
                 <a:solidFill>
                   <a:srgbClr val="820AD1"/>
                 </a:solidFill>
-                <a:latin typeface="DM Sans"/>
+                <a:latin typeface="Arial"/>
               </a:rPr>
               <a:t>1. TAX SUBSTANCE (GATE 1, D+30) [1]</a:t>
             </a:r>
@@ -6524,7 +6513,7 @@
                 <a:solidFill>
                   <a:srgbClr val="11052C"/>
                 </a:solidFill>
-                <a:latin typeface="Space Grotesk"/>
+                <a:latin typeface="Arial"/>
               </a:rPr>
               <a:t>Incentives tied to real payroll</a:t>
             </a:r>
@@ -6559,7 +6548,7 @@
                 <a:solidFill>
                   <a:srgbClr val="3B2A54"/>
                 </a:solidFill>
-                <a:latin typeface="DM Sans"/>
+                <a:latin typeface="Arial"/>
               </a:rPr>
               <a:t>The rule: </a:t>
             </a:r>
@@ -6568,7 +6557,7 @@
                 <a:solidFill>
                   <a:srgbClr val="3B2A54"/>
                 </a:solidFill>
-                <a:latin typeface="DM Sans"/>
+                <a:latin typeface="Arial"/>
               </a:rPr>
               <a:t>Nu is above the EUR 750M Pillar Two threshold. In 2026 only 9.4% of payroll and 7.4% of tangible assets are carved out of the 15% top-up base, so incentives without people and assets on the ground are worth less than they look.</a:t>
             </a:r>
@@ -6580,7 +6569,7 @@
                 <a:solidFill>
                   <a:srgbClr val="3B2A54"/>
                 </a:solidFill>
-                <a:latin typeface="DM Sans"/>
+                <a:latin typeface="Arial"/>
               </a:rPr>
               <a:t>My action: </a:t>
             </a:r>
@@ -6589,7 +6578,7 @@
                 <a:solidFill>
                   <a:srgbClr val="3B2A54"/>
                 </a:solidFill>
-                <a:latin typeface="DM Sans"/>
+                <a:latin typeface="Arial"/>
               </a:rPr>
               <a:t>campus build-out grants and payroll credits. Tax owns the gate; exit test: modeled effective rate holds under Pillar Two.</a:t>
             </a:r>
@@ -6624,7 +6613,7 @@
                 <a:solidFill>
                   <a:srgbClr val="5B21B6"/>
                 </a:solidFill>
-                <a:latin typeface="DM Sans"/>
+                <a:latin typeface="Arial"/>
               </a:rPr>
               <a:t>2. GRANT TERMS (GATE 2, D+60) [2]</a:t>
             </a:r>
@@ -6659,7 +6648,7 @@
                 <a:solidFill>
                   <a:srgbClr val="11052C"/>
                 </a:solidFill>
-                <a:latin typeface="Space Grotesk"/>
+                <a:latin typeface="Arial"/>
               </a:rPr>
               <a:t>Proportional, clawback-proof</a:t>
             </a:r>
@@ -6694,7 +6683,7 @@
                 <a:solidFill>
                   <a:srgbClr val="3B2A54"/>
                 </a:solidFill>
-                <a:latin typeface="DM Sans"/>
+                <a:latin typeface="Arial"/>
               </a:rPr>
               <a:t>The risk: </a:t>
             </a:r>
@@ -6703,7 +6692,7 @@
                 <a:solidFill>
                   <a:srgbClr val="3B2A54"/>
                 </a:solidFill>
-                <a:latin typeface="DM Sans"/>
+                <a:latin typeface="Arial"/>
               </a:rPr>
               <a:t>municipal grants carry headcount clawbacks that bite when hiring pace or hybrid work changes.</a:t>
             </a:r>
@@ -6715,7 +6704,7 @@
                 <a:solidFill>
                   <a:srgbClr val="3B2A54"/>
                 </a:solidFill>
-                <a:latin typeface="DM Sans"/>
+                <a:latin typeface="Arial"/>
               </a:rPr>
               <a:t>My action: </a:t>
             </a:r>
@@ -6724,7 +6713,7 @@
                 <a:solidFill>
                   <a:srgbClr val="3B2A54"/>
                 </a:solidFill>
-                <a:latin typeface="DM Sans"/>
+                <a:latin typeface="Arial"/>
               </a:rPr>
               <a:t>proportional scaling (85% of headcount keeps 85% of the grant) and a 24-month grace period. Legal owns the gate; exit test: no cliff-edge clawback in the signed term sheet.</a:t>
             </a:r>
@@ -6759,7 +6748,7 @@
                 <a:solidFill>
                   <a:srgbClr val="0D9488"/>
                 </a:solidFill>
-                <a:latin typeface="DM Sans"/>
+                <a:latin typeface="Arial"/>
               </a:rPr>
               <a:t>3. OFFICERS (GATE 3, D+90) [3]</a:t>
             </a:r>
@@ -6794,7 +6783,7 @@
                 <a:solidFill>
                   <a:srgbClr val="11052C"/>
                 </a:solidFill>
-                <a:latin typeface="Space Grotesk"/>
+                <a:latin typeface="Arial"/>
               </a:rPr>
               <a:t>Fit-and-proper officers, D&amp;O</a:t>
             </a:r>
@@ -6829,7 +6818,7 @@
                 <a:solidFill>
                   <a:srgbClr val="3B2A54"/>
                 </a:solidFill>
-                <a:latin typeface="DM Sans"/>
+                <a:latin typeface="Arial"/>
               </a:rPr>
               <a:t>The risk: </a:t>
             </a:r>
@@ -6838,7 +6827,7 @@
                 <a:solidFill>
                   <a:srgbClr val="3B2A54"/>
                 </a:solidFill>
-                <a:latin typeface="DM Sans"/>
+                <a:latin typeface="Arial"/>
               </a:rPr>
               <a:t>statutory directors carry personal liability for tax and labor filings; early commercial signing can create a taxable presence before the entity is ready.</a:t>
             </a:r>
@@ -6850,7 +6839,7 @@
                 <a:solidFill>
                   <a:srgbClr val="3B2A54"/>
                 </a:solidFill>
-                <a:latin typeface="DM Sans"/>
+                <a:latin typeface="Arial"/>
               </a:rPr>
               <a:t>My action: </a:t>
             </a:r>
@@ -6859,7 +6848,7 @@
                 <a:solidFill>
                   <a:srgbClr val="3B2A54"/>
                 </a:solidFill>
-                <a:latin typeface="DM Sans"/>
+                <a:latin typeface="Arial"/>
               </a:rPr>
               <a:t>officers who pass the regulator's test, dual signature above category limits, D&amp;O bound before activation. Legal and People own the gate. Gate 4 (D+120): the lease.</a:t>
             </a:r>
@@ -6894,7 +6883,7 @@
                 <a:solidFill>
                   <a:srgbClr val="6B5B82"/>
                 </a:solidFill>
-                <a:latin typeface="DM Sans"/>
+                <a:latin typeface="Arial"/>
               </a:rPr>
               <a:t>15</a:t>
             </a:r>
@@ -7099,7 +7088,7 @@
                 <a:solidFill>
                   <a:srgbClr val="820AD1"/>
                 </a:solidFill>
-                <a:latin typeface="DM Sans"/>
+                <a:latin typeface="Arial"/>
               </a:rPr>
               <a:t>15 // DELIVERABLE 4: HOW I LEAD</a:t>
             </a:r>
@@ -7138,7 +7127,7 @@
                 <a:solidFill>
                   <a:srgbClr val="11052C"/>
                 </a:solidFill>
-                <a:latin typeface="Space Grotesk"/>
+                <a:latin typeface="Arial"/>
               </a:rPr>
               <a:t>How I lead without line authority: three rules I hold myself to, and what I would not touch in the first 90 days</a:t>
             </a:r>
@@ -7173,7 +7162,7 @@
                 <a:solidFill>
                   <a:srgbClr val="6B5B82"/>
                 </a:solidFill>
-                <a:latin typeface="DM Sans"/>
+                <a:latin typeface="Arial"/>
               </a:rPr>
               <a:t>Sources: the fair-process principle follows Kim and Mauborgne (HBR). The rest is how I work; examples from my own record are in the speaker notes and are the first thing I would share in Q&amp;A.</a:t>
             </a:r>
@@ -7208,7 +7197,7 @@
                 <a:solidFill>
                   <a:srgbClr val="820AD1"/>
                 </a:solidFill>
-                <a:latin typeface="DM Sans"/>
+                <a:latin typeface="Arial"/>
               </a:rPr>
               <a:t>1. FAIR PROCESS FIRST</a:t>
             </a:r>
@@ -7243,7 +7232,7 @@
                 <a:solidFill>
                   <a:srgbClr val="11052C"/>
                 </a:solidFill>
-                <a:latin typeface="Space Grotesk"/>
+                <a:latin typeface="Arial"/>
               </a:rPr>
               <a:t>Publish the rule, then negotiate</a:t>
             </a:r>
@@ -7278,7 +7267,7 @@
                 <a:solidFill>
                   <a:srgbClr val="3B2A54"/>
                 </a:solidFill>
-                <a:latin typeface="DM Sans"/>
+                <a:latin typeface="Arial"/>
               </a:rPr>
               <a:t>The rule: </a:t>
             </a:r>
@@ -7287,7 +7276,7 @@
                 <a:solidFill>
                   <a:srgbClr val="3B2A54"/>
                 </a:solidFill>
-                <a:latin typeface="DM Sans"/>
+                <a:latin typeface="Arial"/>
               </a:rPr>
               <a:t>people accept outcomes they argued against when the criteria were public before the decision. I publish the scoring rubric on day one and never change it mid-cycle.</a:t>
             </a:r>
@@ -7299,7 +7288,7 @@
                 <a:solidFill>
                   <a:srgbClr val="3B2A54"/>
                 </a:solidFill>
-                <a:latin typeface="DM Sans"/>
+                <a:latin typeface="Arial"/>
               </a:rPr>
               <a:t>In practice: </a:t>
             </a:r>
@@ -7308,7 +7297,7 @@
                 <a:solidFill>
                   <a:srgbClr val="3B2A54"/>
                 </a:solidFill>
-                <a:latin typeface="DM Sans"/>
+                <a:latin typeface="Arial"/>
               </a:rPr>
               <a:t>every GM sees the same four indicators and the same release rule.</a:t>
             </a:r>
@@ -7343,7 +7332,7 @@
                 <a:solidFill>
                   <a:srgbClr val="5B21B6"/>
                 </a:solidFill>
-                <a:latin typeface="DM Sans"/>
+                <a:latin typeface="Arial"/>
               </a:rPr>
               <a:t>2. NO PUBLIC AMBUSHES</a:t>
             </a:r>
@@ -7378,7 +7367,7 @@
                 <a:solidFill>
                   <a:srgbClr val="11052C"/>
                 </a:solidFill>
-                <a:latin typeface="Space Grotesk"/>
+                <a:latin typeface="Arial"/>
               </a:rPr>
               <a:t>Fix the numbers privately</a:t>
             </a:r>
@@ -7413,7 +7402,7 @@
                 <a:solidFill>
                   <a:srgbClr val="3B2A54"/>
                 </a:solidFill>
-                <a:latin typeface="DM Sans"/>
+                <a:latin typeface="Arial"/>
               </a:rPr>
               <a:t>The rule: </a:t>
             </a:r>
@@ -7422,7 +7411,7 @@
                 <a:solidFill>
                   <a:srgbClr val="3B2A54"/>
                 </a:solidFill>
-                <a:latin typeface="DM Sans"/>
+                <a:latin typeface="Arial"/>
               </a:rPr>
               <a:t>model gaps are closed one-to-one before anything reaches the CFO or the Board. Credibility with senior people comes from never surprising them in a room.</a:t>
             </a:r>
@@ -7434,7 +7423,7 @@
                 <a:solidFill>
                   <a:srgbClr val="3B2A54"/>
                 </a:solidFill>
-                <a:latin typeface="DM Sans"/>
+                <a:latin typeface="Arial"/>
               </a:rPr>
               <a:t>In practice: </a:t>
             </a:r>
@@ -7443,7 +7432,7 @@
                 <a:solidFill>
                   <a:srgbClr val="3B2A54"/>
                 </a:solidFill>
-                <a:latin typeface="DM Sans"/>
+                <a:latin typeface="Arial"/>
               </a:rPr>
               <a:t>the bi-weekly GM one-to-ones and the T-16 lock exist for this.</a:t>
             </a:r>
@@ -7478,7 +7467,7 @@
                 <a:solidFill>
                   <a:srgbClr val="0D9488"/>
                 </a:solidFill>
-                <a:latin typeface="DM Sans"/>
+                <a:latin typeface="Arial"/>
               </a:rPr>
               <a:t>3. HANDS-ON RIGOR</a:t>
             </a:r>
@@ -7513,7 +7502,7 @@
                 <a:solidFill>
                   <a:srgbClr val="11052C"/>
                 </a:solidFill>
-                <a:latin typeface="Space Grotesk"/>
+                <a:latin typeface="Arial"/>
               </a:rPr>
               <a:t>Own the model and the clauses</a:t>
             </a:r>
@@ -7548,7 +7537,7 @@
                 <a:solidFill>
                   <a:srgbClr val="3B2A54"/>
                 </a:solidFill>
-                <a:latin typeface="DM Sans"/>
+                <a:latin typeface="Arial"/>
               </a:rPr>
               <a:t>The rule: </a:t>
             </a:r>
@@ -7557,9 +7546,9 @@
                 <a:solidFill>
                   <a:srgbClr val="3B2A54"/>
                 </a:solidFill>
-                <a:latin typeface="DM Sans"/>
-              </a:rPr>
-              <a:t>strategic influence is only trusted when the hands-on FP&amp;A and governance rigor is mine. I build and check the model and read the clauses myself; I do not delegate what can embarrass the CFO.</a:t>
+                <a:latin typeface="Arial"/>
+              </a:rPr>
+              <a:t>influence is only trusted when the hands-on FP&amp;A and governance rigor is mine. I build the model and read the clauses myself.</a:t>
             </a:r>
           </a:p>
           <a:p>
@@ -7569,7 +7558,7 @@
                 <a:solidFill>
                   <a:srgbClr val="3B2A54"/>
                 </a:solidFill>
-                <a:latin typeface="DM Sans"/>
+                <a:latin typeface="Arial"/>
               </a:rPr>
               <a:t>What I would not touch: </a:t>
             </a:r>
@@ -7578,7 +7567,7 @@
                 <a:solidFill>
                   <a:srgbClr val="3B2A54"/>
                 </a:solidFill>
-                <a:latin typeface="DM Sans"/>
+                <a:latin typeface="Arial"/>
               </a:rPr>
               <a:t>local-CFO decision rights in Mexico and Colombia, credit-model governance, the IR calendar.</a:t>
             </a:r>
@@ -7613,7 +7602,7 @@
                 <a:solidFill>
                   <a:srgbClr val="6B5B82"/>
                 </a:solidFill>
-                <a:latin typeface="DM Sans"/>
+                <a:latin typeface="Arial"/>
               </a:rPr>
               <a:t>16</a:t>
             </a:r>
@@ -7699,7 +7688,7 @@
                           <a:solidFill>
                             <a:srgbClr val="FFFFFF"/>
                           </a:solidFill>
-                          <a:latin typeface="Space Grotesk"/>
+                          <a:latin typeface="Arial"/>
                         </a:rPr>
                         <a:t>Operating Rhythm</a:t>
                       </a:r>
@@ -7734,7 +7723,7 @@
                           <a:solidFill>
                             <a:srgbClr val="FFFFFF"/>
                           </a:solidFill>
-                          <a:latin typeface="Space Grotesk"/>
+                          <a:latin typeface="Arial"/>
                         </a:rPr>
                         <a:t>Cadence</a:t>
                       </a:r>
@@ -7769,7 +7758,7 @@
                           <a:solidFill>
                             <a:srgbClr val="FFFFFF"/>
                           </a:solidFill>
-                          <a:latin typeface="Space Grotesk"/>
+                          <a:latin typeface="Arial"/>
                         </a:rPr>
                         <a:t>What happens</a:t>
                       </a:r>
@@ -7804,7 +7793,7 @@
                           <a:solidFill>
                             <a:srgbClr val="FFFFFF"/>
                           </a:solidFill>
-                          <a:latin typeface="Space Grotesk"/>
+                          <a:latin typeface="Arial"/>
                         </a:rPr>
                         <a:t>Owner and output</a:t>
                       </a:r>
@@ -7841,7 +7830,7 @@
                           <a:solidFill>
                             <a:srgbClr val="11052C"/>
                           </a:solidFill>
-                          <a:latin typeface="DM Sans"/>
+                          <a:latin typeface="Arial"/>
                         </a:rPr>
                         <a:t>1. Embedded Squad Clinics</a:t>
                       </a:r>
@@ -7876,7 +7865,7 @@
                           <a:solidFill>
                             <a:srgbClr val="11052C"/>
                           </a:solidFill>
-                          <a:latin typeface="DM Sans"/>
+                          <a:latin typeface="Arial"/>
                         </a:rPr>
                         <a:t>Weekly</a:t>
                       </a:r>
@@ -7911,7 +7900,7 @@
                           <a:solidFill>
                             <a:srgbClr val="11052C"/>
                           </a:solidFill>
-                          <a:latin typeface="DM Sans"/>
+                          <a:latin typeface="Arial"/>
                         </a:rPr>
                         <a:t>Finance partners join the country and vertical stand-ups and model unit economics with the GMs before anything reaches formal review.</a:t>
                       </a:r>
@@ -7946,7 +7935,7 @@
                           <a:solidFill>
                             <a:srgbClr val="11052C"/>
                           </a:solidFill>
-                          <a:latin typeface="DM Sans"/>
+                          <a:latin typeface="Arial"/>
                         </a:rPr>
                         <a:t>Finance partner. Output: a business case in the standard template, co-signed by the GM.</a:t>
                       </a:r>
@@ -7983,7 +7972,7 @@
                           <a:solidFill>
                             <a:srgbClr val="11052C"/>
                           </a:solidFill>
-                          <a:latin typeface="DM Sans"/>
+                          <a:latin typeface="Arial"/>
                         </a:rPr>
                         <a:t>2. Bilateral Pre-Alignment</a:t>
                       </a:r>
@@ -8018,7 +8007,7 @@
                           <a:solidFill>
                             <a:srgbClr val="11052C"/>
                           </a:solidFill>
-                          <a:latin typeface="DM Sans"/>
+                          <a:latin typeface="Arial"/>
                         </a:rPr>
                         <a:t>Bi-Weekly</a:t>
                       </a:r>
@@ -8053,7 +8042,7 @@
                           <a:solidFill>
                             <a:srgbClr val="11052C"/>
                           </a:solidFill>
-                          <a:latin typeface="DM Sans"/>
+                          <a:latin typeface="Arial"/>
                         </a:rPr>
                         <a:t>I meet each GM privately to stress-test assumptions and design the staged option before it is seen by the CFO.</a:t>
                       </a:r>
@@ -8088,7 +8077,7 @@
                           <a:solidFill>
                             <a:srgbClr val="11052C"/>
                           </a:solidFill>
-                          <a:latin typeface="DM Sans"/>
+                          <a:latin typeface="Arial"/>
                         </a:rPr>
                         <a:t>Me. Output: no surprises at the T-16 lock; every ask has a conditional-yes path.</a:t>
                       </a:r>
@@ -8125,7 +8114,7 @@
                           <a:solidFill>
                             <a:srgbClr val="11052C"/>
                           </a:solidFill>
-                          <a:latin typeface="DM Sans"/>
+                          <a:latin typeface="Arial"/>
                         </a:rPr>
                         <a:t>3. HQ pod</a:t>
                       </a:r>
@@ -8134,7 +8123,7 @@
                           <a:solidFill>
                             <a:srgbClr val="11052C"/>
                           </a:solidFill>
-                          <a:latin typeface="DM Sans"/>
+                          <a:latin typeface="Arial"/>
                         </a:rPr>
                         <a:t> (Deliverable 3)</a:t>
                       </a:r>
@@ -8169,7 +8158,7 @@
                           <a:solidFill>
                             <a:srgbClr val="11052C"/>
                           </a:solidFill>
-                          <a:latin typeface="DM Sans"/>
+                          <a:latin typeface="Arial"/>
                         </a:rPr>
                         <a:t>Weekly (45m)</a:t>
                       </a:r>
@@ -8204,7 +8193,7 @@
                           <a:solidFill>
                             <a:srgbClr val="11052C"/>
                           </a:solidFill>
-                          <a:latin typeface="DM Sans"/>
+                          <a:latin typeface="Arial"/>
                         </a:rPr>
                         <a:t>Legal, Tax, Workplace and People leads around one decision log with 48-hour escalation to the CFO.</a:t>
                       </a:r>
@@ -8239,7 +8228,7 @@
                           <a:solidFill>
                             <a:srgbClr val="11052C"/>
                           </a:solidFill>
-                          <a:latin typeface="DM Sans"/>
+                          <a:latin typeface="Arial"/>
                         </a:rPr>
                         <a:t>Me (chair). Output: the gate pack for the next HQ gate, with owner and exit test.</a:t>
                       </a:r>
@@ -8276,7 +8265,7 @@
                           <a:solidFill>
                             <a:srgbClr val="11052C"/>
                           </a:solidFill>
-                          <a:latin typeface="DM Sans"/>
+                          <a:latin typeface="Arial"/>
                         </a:rPr>
                         <a:t>4. Quarterly Tranche Release</a:t>
                       </a:r>
@@ -8311,7 +8300,7 @@
                           <a:solidFill>
                             <a:srgbClr val="11052C"/>
                           </a:solidFill>
-                          <a:latin typeface="DM Sans"/>
+                          <a:latin typeface="Arial"/>
                         </a:rPr>
                         <a:t>Quarterly</a:t>
                       </a:r>
@@ -8346,7 +8335,7 @@
                           <a:solidFill>
                             <a:srgbClr val="11052C"/>
                           </a:solidFill>
-                          <a:latin typeface="DM Sans"/>
+                          <a:latin typeface="Arial"/>
                         </a:rPr>
                         <a:t>Read the four indicators per unit against plan and release or hold the next stage.</a:t>
                       </a:r>
@@ -8381,7 +8370,7 @@
                           <a:solidFill>
                             <a:srgbClr val="11052C"/>
                           </a:solidFill>
-                          <a:latin typeface="DM Sans"/>
+                          <a:latin typeface="Arial"/>
                         </a:rPr>
                         <a:t>CFO decides on my recommendation. Output: release memo, published to the GMs the same day.</a:t>
                       </a:r>
@@ -8438,7 +8427,7 @@
                 <a:solidFill>
                   <a:srgbClr val="820AD1"/>
                 </a:solidFill>
-                <a:latin typeface="DM Sans"/>
+                <a:latin typeface="Arial"/>
               </a:rPr>
               <a:t>08 // DELIVERABLE 1: THE CADENCE</a:t>
             </a:r>
@@ -8477,9 +8466,9 @@
                 <a:solidFill>
                   <a:srgbClr val="11052C"/>
                 </a:solidFill>
-                <a:latin typeface="Space Grotesk"/>
-              </a:rPr>
-              <a:t>Four meetings, each with an owner and an output; nothing else is added</a:t>
+                <a:latin typeface="Arial"/>
+              </a:rPr>
+              <a:t>Four meetings, each with an owner and an output</a:t>
             </a:r>
           </a:p>
         </p:txBody>
@@ -8512,7 +8501,7 @@
                 <a:solidFill>
                   <a:srgbClr val="6B5B82"/>
                 </a:solidFill>
-                <a:latin typeface="DM Sans"/>
+                <a:latin typeface="Arial"/>
               </a:rPr>
               <a:t>Decision roles follow a RAPID-style split: finance partners recommend, GMs provide input, I assemble the pack, the CFO decides, the hub performs.</a:t>
             </a:r>
@@ -8547,7 +8536,7 @@
                 <a:solidFill>
                   <a:srgbClr val="6B5B82"/>
                 </a:solidFill>
-                <a:latin typeface="DM Sans"/>
+                <a:latin typeface="Arial"/>
               </a:rPr>
               <a:t>9</a:t>
             </a:r>
@@ -8846,7 +8835,7 @@
                 <a:solidFill>
                   <a:srgbClr val="820AD1"/>
                 </a:solidFill>
-                <a:latin typeface="DM Sans"/>
+                <a:latin typeface="Arial"/>
               </a:rPr>
               <a:t>10 // DELIVERABLE 2: WHEN A SENIOR GM PUSHES BACK</a:t>
             </a:r>
@@ -8885,7 +8874,7 @@
                 <a:solidFill>
                   <a:srgbClr val="11052C"/>
                 </a:solidFill>
-                <a:latin typeface="Space Grotesk"/>
+                <a:latin typeface="Arial"/>
               </a:rPr>
               <a:t>When a senior GM pushes back: validate the goal privately, move to criteria, offer a conditional yes, co-present the result</a:t>
             </a:r>
@@ -8920,7 +8909,7 @@
                 <a:solidFill>
                   <a:srgbClr val="6B5B82"/>
                 </a:solidFill>
-                <a:latin typeface="DM Sans"/>
+                <a:latin typeface="Arial"/>
               </a:rPr>
               <a:t>Source: Kim and Mauborgne, 'Fair Process: Managing in the Knowledge Economy', Harvard Business Review. Everything else on this slide is practice, not research.</a:t>
             </a:r>
@@ -8955,7 +8944,7 @@
                 <a:solidFill>
                   <a:srgbClr val="FFFFFF"/>
                 </a:solidFill>
-                <a:latin typeface="DM Sans"/>
+                <a:latin typeface="Arial"/>
               </a:rPr>
               <a:t>Why this works without line authority: </a:t>
             </a:r>
@@ -8964,7 +8953,7 @@
                 <a:solidFill>
                   <a:srgbClr val="FFFFFF"/>
                 </a:solidFill>
-                <a:latin typeface="DM Sans"/>
+                <a:latin typeface="Arial"/>
               </a:rPr>
               <a:t>fair process (early engagement, a clear explanation, published expectations) is what makes senior people accept an outcome they argued against. The rule is public on day one; the conversation is private; the sign-off is joint.</a:t>
             </a:r>
@@ -8999,7 +8988,7 @@
                 <a:solidFill>
                   <a:srgbClr val="820AD1"/>
                 </a:solidFill>
-                <a:latin typeface="DM Sans"/>
+                <a:latin typeface="Arial"/>
               </a:rPr>
               <a:t>STEP 1 // DE-ESCALATE</a:t>
             </a:r>
@@ -9034,7 +9023,7 @@
                 <a:solidFill>
                   <a:srgbClr val="11052C"/>
                 </a:solidFill>
-                <a:latin typeface="Space Grotesk"/>
+                <a:latin typeface="Arial"/>
               </a:rPr>
               <a:t>Separate the person from the numbers</a:t>
             </a:r>
@@ -9069,7 +9058,7 @@
                 <a:solidFill>
                   <a:srgbClr val="3B2A54"/>
                 </a:solidFill>
-                <a:latin typeface="DM Sans"/>
+                <a:latin typeface="Arial"/>
               </a:rPr>
               <a:t>I meet the GM privately first and confirm the strategic goal before any budget line is discussed. Nobody is corrected in front of the CFO.</a:t>
             </a:r>
@@ -9104,7 +9093,7 @@
                 <a:solidFill>
                   <a:srgbClr val="5B21B6"/>
                 </a:solidFill>
-                <a:latin typeface="DM Sans"/>
+                <a:latin typeface="Arial"/>
               </a:rPr>
               <a:t>STEP 2 // REFRAME</a:t>
             </a:r>
@@ -9139,7 +9128,7 @@
                 <a:solidFill>
                   <a:srgbClr val="11052C"/>
                 </a:solidFill>
-                <a:latin typeface="Space Grotesk"/>
+                <a:latin typeface="Arial"/>
               </a:rPr>
               <a:t>From positions to criteria</a:t>
             </a:r>
@@ -9174,7 +9163,7 @@
                 <a:solidFill>
                   <a:srgbClr val="3B2A54"/>
                 </a:solidFill>
-                <a:latin typeface="DM Sans"/>
+                <a:latin typeface="Arial"/>
               </a:rPr>
               <a:t>Move from 'I need $25M' to 'which indicators would prove this works?' The published rule does the arguing, not me.</a:t>
             </a:r>
@@ -9209,7 +9198,7 @@
                 <a:solidFill>
                   <a:srgbClr val="D97706"/>
                 </a:solidFill>
-                <a:latin typeface="DM Sans"/>
+                <a:latin typeface="Arial"/>
               </a:rPr>
               <a:t>STEP 3 // CO-DESIGN</a:t>
             </a:r>
@@ -9244,7 +9233,7 @@
                 <a:solidFill>
                   <a:srgbClr val="11052C"/>
                 </a:solidFill>
-                <a:latin typeface="Space Grotesk"/>
+                <a:latin typeface="Arial"/>
               </a:rPr>
               <a:t>Offer a conditional yes</a:t>
             </a:r>
@@ -9279,7 +9268,7 @@
                 <a:solidFill>
                   <a:srgbClr val="3B2A54"/>
                 </a:solidFill>
-                <a:latin typeface="DM Sans"/>
+                <a:latin typeface="Arial"/>
               </a:rPr>
               <a:t>Replace a flat no with a staged yes: the $4.5M Q1 start today and a reserved claim on gate 2 once the indicators hold.</a:t>
             </a:r>
@@ -9314,7 +9303,7 @@
                 <a:solidFill>
                   <a:srgbClr val="0D9488"/>
                 </a:solidFill>
-                <a:latin typeface="DM Sans"/>
+                <a:latin typeface="Arial"/>
               </a:rPr>
               <a:t>STEP 4 // INSTITUTIONALIZE</a:t>
             </a:r>
@@ -9349,7 +9338,7 @@
                 <a:solidFill>
                   <a:srgbClr val="11052C"/>
                 </a:solidFill>
-                <a:latin typeface="Space Grotesk"/>
+                <a:latin typeface="Arial"/>
               </a:rPr>
               <a:t>Co-present at the lock</a:t>
             </a:r>
@@ -9384,7 +9373,7 @@
                 <a:solidFill>
                   <a:srgbClr val="3B2A54"/>
                 </a:solidFill>
-                <a:latin typeface="DM Sans"/>
+                <a:latin typeface="Arial"/>
               </a:rPr>
               <a:t>The GM and I present the staged plan together at the T-16 lock. There is no back channel to the CEO because there is nothing left to appeal.</a:t>
             </a:r>
@@ -9419,7 +9408,7 @@
                 <a:solidFill>
                   <a:srgbClr val="6B5B82"/>
                 </a:solidFill>
-                <a:latin typeface="DM Sans"/>
+                <a:latin typeface="Arial"/>
               </a:rPr>
               <a:t>11</a:t>
             </a:r>
@@ -9505,7 +9494,7 @@
                           <a:solidFill>
                             <a:srgbClr val="FFFFFF"/>
                           </a:solidFill>
-                          <a:latin typeface="Space Grotesk"/>
+                          <a:latin typeface="Arial"/>
                         </a:rPr>
                         <a:t>Dimension</a:t>
                       </a:r>
@@ -9540,7 +9529,7 @@
                           <a:solidFill>
                             <a:srgbClr val="FFFFFF"/>
                           </a:solidFill>
-                          <a:latin typeface="Space Grotesk"/>
+                          <a:latin typeface="Arial"/>
                         </a:rPr>
                         <a:t>Downside (market slows)</a:t>
                       </a:r>
@@ -9575,7 +9564,7 @@
                           <a:solidFill>
                             <a:srgbClr val="FFFFFF"/>
                           </a:solidFill>
-                          <a:latin typeface="Space Grotesk"/>
+                          <a:latin typeface="Arial"/>
                         </a:rPr>
                         <a:t>Base plan</a:t>
                       </a:r>
@@ -9610,7 +9599,7 @@
                           <a:solidFill>
                             <a:srgbClr val="FFFFFF"/>
                           </a:solidFill>
-                          <a:latin typeface="Space Grotesk"/>
+                          <a:latin typeface="Arial"/>
                         </a:rPr>
                         <a:t>Upside (H1 beats plan)</a:t>
                       </a:r>
@@ -9647,7 +9636,7 @@
                           <a:solidFill>
                             <a:srgbClr val="11052C"/>
                           </a:solidFill>
-                          <a:latin typeface="DM Sans"/>
+                          <a:latin typeface="Arial"/>
                         </a:rPr>
                         <a:t>1. Funded spend vs the $25M cap</a:t>
                       </a:r>
@@ -9682,7 +9671,7 @@
                           <a:solidFill>
                             <a:srgbClr val="11052C"/>
                           </a:solidFill>
-                          <a:latin typeface="DM Sans"/>
+                          <a:latin typeface="Arial"/>
                         </a:rPr>
                         <a:t>$15.0M (gate 2 held at Q1 close)</a:t>
                       </a:r>
@@ -9717,7 +9706,7 @@
                           <a:solidFill>
                             <a:srgbClr val="11052C"/>
                           </a:solidFill>
-                          <a:latin typeface="DM Sans"/>
+                          <a:latin typeface="Arial"/>
                         </a:rPr>
                         <a:t>$25.0M ($15M gate 1 + $10M gate 2)</a:t>
                       </a:r>
@@ -9752,7 +9741,7 @@
                           <a:solidFill>
                             <a:srgbClr val="11052C"/>
                           </a:solidFill>
-                          <a:latin typeface="DM Sans"/>
+                          <a:latin typeface="Arial"/>
                         </a:rPr>
                         <a:t>$25.0M</a:t>
                       </a:r>
@@ -9789,7 +9778,7 @@
                           <a:solidFill>
                             <a:srgbClr val="11052C"/>
                           </a:solidFill>
-                          <a:latin typeface="DM Sans"/>
+                          <a:latin typeface="Arial"/>
                         </a:rPr>
                         <a:t>2. Release above the cap (rule A6)</a:t>
                       </a:r>
@@ -9824,7 +9813,7 @@
                           <a:solidFill>
                             <a:srgbClr val="11052C"/>
                           </a:solidFill>
-                          <a:latin typeface="DM Sans"/>
+                          <a:latin typeface="Arial"/>
                         </a:rPr>
                         <a:t>$0</a:t>
                       </a:r>
@@ -9859,7 +9848,7 @@
                           <a:solidFill>
                             <a:srgbClr val="11052C"/>
                           </a:solidFill>
-                          <a:latin typeface="DM Sans"/>
+                          <a:latin typeface="Arial"/>
                         </a:rPr>
                         <a:t>$0 (not assumed)</a:t>
                       </a:r>
@@ -9894,7 +9883,7 @@
                           <a:solidFill>
                             <a:srgbClr val="11052C"/>
                           </a:solidFill>
-                          <a:latin typeface="DM Sans"/>
+                          <a:latin typeface="Arial"/>
                         </a:rPr>
                         <a:t>Up to $15.0M from H1 profit above plan, inside the ~20% FY26 guide</a:t>
                       </a:r>
@@ -9931,7 +9920,7 @@
                           <a:solidFill>
                             <a:srgbClr val="11052C"/>
                           </a:solidFill>
-                          <a:latin typeface="DM Sans"/>
+                          <a:latin typeface="Arial"/>
                         </a:rPr>
                         <a:t>3. Reversal triggers (stop or hold)</a:t>
                       </a:r>
@@ -9966,7 +9955,7 @@
                           <a:solidFill>
                             <a:srgbClr val="11052C"/>
                           </a:solidFill>
-                          <a:latin typeface="DM Sans"/>
+                          <a:latin typeface="Arial"/>
                         </a:rPr>
                         <a:t>A unit below plan on two of four indicators: its gate-2 share is held</a:t>
                       </a:r>
@@ -10001,7 +9990,7 @@
                           <a:solidFill>
                             <a:srgbClr val="11052C"/>
                           </a:solidFill>
-                          <a:latin typeface="DM Sans"/>
+                          <a:latin typeface="Arial"/>
                         </a:rPr>
                         <a:t>Efficiency ratio above the FY26 guide at Q1 close: gate 2 held for all units</a:t>
                       </a:r>
@@ -10036,7 +10025,7 @@
                           <a:solidFill>
                             <a:srgbClr val="11052C"/>
                           </a:solidFill>
-                          <a:latin typeface="DM Sans"/>
+                          <a:latin typeface="Arial"/>
                         </a:rPr>
                         <a:t>Credit cost or NPL 90+ above plan: rule A6 is not used</a:t>
                       </a:r>
@@ -10073,7 +10062,7 @@
                           <a:solidFill>
                             <a:srgbClr val="11052C"/>
                           </a:solidFill>
-                          <a:latin typeface="DM Sans"/>
+                          <a:latin typeface="Arial"/>
                         </a:rPr>
                         <a:t>4. Top risks and owners</a:t>
                       </a:r>
@@ -10108,7 +10097,7 @@
                           <a:solidFill>
                             <a:srgbClr val="11052C"/>
                           </a:solidFill>
-                          <a:latin typeface="DM Sans"/>
+                          <a:latin typeface="Arial"/>
                         </a:rPr>
                         <a:t>GMs game the indicators: finance partners own the read-out</a:t>
                       </a:r>
@@ -10143,7 +10132,7 @@
                           <a:solidFill>
                             <a:srgbClr val="11052C"/>
                           </a:solidFill>
-                          <a:latin typeface="DM Sans"/>
+                          <a:latin typeface="Arial"/>
                         </a:rPr>
                         <a:t>Board book slips: outline locked today; anything outside it goes to the appendix</a:t>
                       </a:r>
@@ -10178,7 +10167,7 @@
                           <a:solidFill>
                             <a:srgbClr val="11052C"/>
                           </a:solidFill>
-                          <a:latin typeface="DM Sans"/>
+                          <a:latin typeface="Arial"/>
                         </a:rPr>
                         <a:t>HQ: tax residence, clawback, officer liability, site politics, key-person risk</a:t>
                       </a:r>
@@ -10215,7 +10204,7 @@
                           <a:solidFill>
                             <a:srgbClr val="11052C"/>
                           </a:solidFill>
-                          <a:latin typeface="DM Sans"/>
+                          <a:latin typeface="Arial"/>
                         </a:rPr>
                         <a:t>5. What I report at Day 90</a:t>
                       </a:r>
@@ -10250,7 +10239,7 @@
                           <a:solidFill>
                             <a:srgbClr val="11052C"/>
                           </a:solidFill>
-                          <a:latin typeface="DM Sans"/>
+                          <a:latin typeface="Arial"/>
                         </a:rPr>
                         <a:t>First monthly indicator read-outs per unit (gate 2 decided at Q1 close)</a:t>
                       </a:r>
@@ -10285,7 +10274,7 @@
                           <a:solidFill>
                             <a:srgbClr val="820AD1"/>
                           </a:solidFill>
-                          <a:latin typeface="DM Sans"/>
+                          <a:latin typeface="Arial"/>
                         </a:rPr>
                         <a:t>Board delivered at T-0; capital plan approved; cycle-time and forecast baselines</a:t>
                       </a:r>
@@ -10320,7 +10309,7 @@
                           <a:solidFill>
                             <a:srgbClr val="11052C"/>
                           </a:solidFill>
-                          <a:latin typeface="DM Sans"/>
+                          <a:latin typeface="Arial"/>
                         </a:rPr>
                         <a:t>HQ gates 1 and 2 cleared; gate 3 pack ready</a:t>
                       </a:r>
@@ -10377,7 +10366,7 @@
                 <a:solidFill>
                   <a:srgbClr val="820AD1"/>
                 </a:solidFill>
-                <a:latin typeface="DM Sans"/>
+                <a:latin typeface="Arial"/>
               </a:rPr>
               <a:t>16 // RISKS, SCENARIOS AND REVERSAL TRIGGERS</a:t>
             </a:r>
@@ -10416,7 +10405,7 @@
                 <a:solidFill>
                   <a:srgbClr val="11052C"/>
                 </a:solidFill>
-                <a:latin typeface="Space Grotesk"/>
+                <a:latin typeface="Arial"/>
               </a:rPr>
               <a:t>If Q1 indicators miss, gate 2 is held; the A6 valve opens only on an H1 profit beat, inside the efficiency guide</a:t>
             </a:r>
@@ -10451,7 +10440,7 @@
                 <a:solidFill>
                   <a:srgbClr val="3B2A54"/>
                 </a:solidFill>
-                <a:latin typeface="DM Sans"/>
+                <a:latin typeface="Arial"/>
               </a:rPr>
               <a:t>For the Board: </a:t>
             </a:r>
@@ -10460,7 +10449,7 @@
                 <a:solidFill>
                   <a:srgbClr val="3B2A54"/>
                 </a:solidFill>
-                <a:latin typeface="DM Sans"/>
+                <a:latin typeface="Arial"/>
               </a:rPr>
               <a:t>funding above $15M is released only on evidence, so margins are protected automatically if conditions tighten, with no mid-year freeze. No value figures are claimed beyond the spend lines; they would be guesses before HQ gate 1.</a:t>
             </a:r>
@@ -10495,7 +10484,7 @@
                 <a:solidFill>
                   <a:srgbClr val="6B5B82"/>
                 </a:solidFill>
-                <a:latin typeface="DM Sans"/>
+                <a:latin typeface="Arial"/>
               </a:rPr>
               <a:t>17</a:t>
             </a:r>
@@ -10700,7 +10689,7 @@
                 <a:solidFill>
                   <a:srgbClr val="820AD1"/>
                 </a:solidFill>
-                <a:latin typeface="DM Sans"/>
+                <a:latin typeface="Arial"/>
               </a:rPr>
               <a:t>17 // THE NEXT 90 DAYS</a:t>
             </a:r>
@@ -10739,7 +10728,7 @@
                 <a:solidFill>
                   <a:srgbClr val="11052C"/>
                 </a:solidFill>
-                <a:latin typeface="Space Grotesk"/>
+                <a:latin typeface="Arial"/>
               </a:rPr>
               <a:t>Days 61-150 (today to mid-January): Board approved by Day 88, hub in place by Day 95, FY27 gate 1 open on 1 January</a:t>
             </a:r>
@@ -10774,7 +10763,7 @@
                 <a:solidFill>
                   <a:srgbClr val="B91C1C"/>
                 </a:solidFill>
-                <a:latin typeface="DM Sans"/>
+                <a:latin typeface="Arial"/>
               </a:rPr>
               <a:t>DAYS 61–90 // ALIGN &amp; STABILIZE</a:t>
             </a:r>
@@ -10809,7 +10798,7 @@
                 <a:solidFill>
                   <a:srgbClr val="11052C"/>
                 </a:solidFill>
-                <a:latin typeface="Space Grotesk"/>
+                <a:latin typeface="Arial"/>
               </a:rPr>
               <a:t>Lock the Board and gate 1</a:t>
             </a:r>
@@ -10844,7 +10833,7 @@
                 <a:solidFill>
                   <a:srgbClr val="820AD1"/>
                 </a:solidFill>
-                <a:latin typeface="DM Sans"/>
+                <a:latin typeface="Arial"/>
               </a:rPr>
               <a:t>DAYS 91–120 // EMBED &amp; NEGOTIATE</a:t>
             </a:r>
@@ -10879,7 +10868,7 @@
                 <a:solidFill>
                   <a:srgbClr val="11052C"/>
                 </a:solidFill>
-                <a:latin typeface="Space Grotesk"/>
+                <a:latin typeface="Arial"/>
               </a:rPr>
               <a:t>Stand up the hub; HQ gate 2</a:t>
             </a:r>
@@ -10914,7 +10903,7 @@
                 <a:solidFill>
                   <a:srgbClr val="0D9488"/>
                 </a:solidFill>
-                <a:latin typeface="DM Sans"/>
+                <a:latin typeface="Arial"/>
               </a:rPr>
               <a:t>DAYS 121–150 // SCALE &amp; EXECUTE</a:t>
             </a:r>
@@ -10949,7 +10938,7 @@
                 <a:solidFill>
                   <a:srgbClr val="11052C"/>
                 </a:solidFill>
-                <a:latin typeface="Space Grotesk"/>
+                <a:latin typeface="Arial"/>
               </a:rPr>
               <a:t>FY27 opens; HQ gate 3</a:t>
             </a:r>
@@ -10984,7 +10973,7 @@
                 <a:solidFill>
                   <a:srgbClr val="3B2A54"/>
                 </a:solidFill>
-                <a:latin typeface="DM Sans"/>
+                <a:latin typeface="Arial"/>
               </a:rPr>
               <a:t>•</a:t>
             </a:r>
@@ -11019,7 +11008,7 @@
                 <a:solidFill>
                   <a:srgbClr val="3B2A54"/>
                 </a:solidFill>
-                <a:latin typeface="DM Sans"/>
+                <a:latin typeface="Arial"/>
               </a:rPr>
               <a:t>Today (T-28): </a:t>
             </a:r>
@@ -11028,7 +11017,7 @@
                 <a:solidFill>
                   <a:srgbClr val="3B2A54"/>
                 </a:solidFill>
-                <a:latin typeface="DM Sans"/>
+                <a:latin typeface="Arial"/>
               </a:rPr>
               <a:t>Board outline issued; HQ charter signed; gate 1 launched.</a:t>
             </a:r>
@@ -11063,7 +11052,7 @@
                 <a:solidFill>
                   <a:srgbClr val="3B2A54"/>
                 </a:solidFill>
-                <a:latin typeface="DM Sans"/>
+                <a:latin typeface="Arial"/>
               </a:rPr>
               <a:t>•</a:t>
             </a:r>
@@ -11098,7 +11087,7 @@
                 <a:solidFill>
                   <a:srgbClr val="3B2A54"/>
                 </a:solidFill>
-                <a:latin typeface="DM Sans"/>
+                <a:latin typeface="Arial"/>
               </a:rPr>
               <a:t>Day 72 (T-16): </a:t>
             </a:r>
@@ -11107,7 +11096,7 @@
                 <a:solidFill>
                   <a:srgbClr val="3B2A54"/>
                 </a:solidFill>
-                <a:latin typeface="DM Sans"/>
+                <a:latin typeface="Arial"/>
               </a:rPr>
               <a:t>options memo settles the 70/30 lock with CEO, CFO, MTeam.</a:t>
             </a:r>
@@ -11142,7 +11131,7 @@
                 <a:solidFill>
                   <a:srgbClr val="3B2A54"/>
                 </a:solidFill>
-                <a:latin typeface="DM Sans"/>
+                <a:latin typeface="Arial"/>
               </a:rPr>
               <a:t>•</a:t>
             </a:r>
@@ -11177,7 +11166,7 @@
                 <a:solidFill>
                   <a:srgbClr val="3B2A54"/>
                 </a:solidFill>
-                <a:latin typeface="DM Sans"/>
+                <a:latin typeface="Arial"/>
               </a:rPr>
               <a:t>Day 88 (T-0): </a:t>
             </a:r>
@@ -11186,7 +11175,7 @@
                 <a:solidFill>
                   <a:srgbClr val="3B2A54"/>
                 </a:solidFill>
-                <a:latin typeface="DM Sans"/>
+                <a:latin typeface="Arial"/>
               </a:rPr>
               <a:t>Board approves the FY27 plan; gate-1 allocation memo published.</a:t>
             </a:r>
@@ -11221,7 +11210,7 @@
                 <a:solidFill>
                   <a:srgbClr val="3B2A54"/>
                 </a:solidFill>
-                <a:latin typeface="DM Sans"/>
+                <a:latin typeface="Arial"/>
               </a:rPr>
               <a:t>•</a:t>
             </a:r>
@@ -11256,7 +11245,7 @@
                 <a:solidFill>
                   <a:srgbClr val="3B2A54"/>
                 </a:solidFill>
-                <a:latin typeface="DM Sans"/>
+                <a:latin typeface="Arial"/>
               </a:rPr>
               <a:t>Day 95: </a:t>
             </a:r>
@@ -11265,7 +11254,7 @@
                 <a:solidFill>
                   <a:srgbClr val="3B2A54"/>
                 </a:solidFill>
-                <a:latin typeface="DM Sans"/>
+                <a:latin typeface="Arial"/>
               </a:rPr>
               <a:t>hub stood up; finance partners embedded in each market and vertical.</a:t>
             </a:r>
@@ -11300,7 +11289,7 @@
                 <a:solidFill>
                   <a:srgbClr val="3B2A54"/>
                 </a:solidFill>
-                <a:latin typeface="DM Sans"/>
+                <a:latin typeface="Arial"/>
               </a:rPr>
               <a:t>•</a:t>
             </a:r>
@@ -11335,7 +11324,7 @@
                 <a:solidFill>
                   <a:srgbClr val="3B2A54"/>
                 </a:solidFill>
-                <a:latin typeface="DM Sans"/>
+                <a:latin typeface="Arial"/>
               </a:rPr>
               <a:t>Day 105: </a:t>
             </a:r>
@@ -11344,7 +11333,7 @@
                 <a:solidFill>
                   <a:srgbClr val="3B2A54"/>
                 </a:solidFill>
-                <a:latin typeface="DM Sans"/>
+                <a:latin typeface="Arial"/>
               </a:rPr>
               <a:t>squad clinics running; $12M case track under way.</a:t>
             </a:r>
@@ -11379,7 +11368,7 @@
                 <a:solidFill>
                   <a:srgbClr val="3B2A54"/>
                 </a:solidFill>
-                <a:latin typeface="DM Sans"/>
+                <a:latin typeface="Arial"/>
               </a:rPr>
               <a:t>•</a:t>
             </a:r>
@@ -11414,7 +11403,7 @@
                 <a:solidFill>
                   <a:srgbClr val="3B2A54"/>
                 </a:solidFill>
-                <a:latin typeface="DM Sans"/>
+                <a:latin typeface="Arial"/>
               </a:rPr>
               <a:t>Day 120 (HQ D+60): </a:t>
             </a:r>
@@ -11423,7 +11412,7 @@
                 <a:solidFill>
                   <a:srgbClr val="3B2A54"/>
                 </a:solidFill>
-                <a:latin typeface="DM Sans"/>
+                <a:latin typeface="Arial"/>
               </a:rPr>
               <a:t>gate 2 cleared: proportional grant terms, 24-month grace.</a:t>
             </a:r>
@@ -11458,7 +11447,7 @@
                 <a:solidFill>
                   <a:srgbClr val="3B2A54"/>
                 </a:solidFill>
-                <a:latin typeface="DM Sans"/>
+                <a:latin typeface="Arial"/>
               </a:rPr>
               <a:t>•</a:t>
             </a:r>
@@ -11493,7 +11482,7 @@
                 <a:solidFill>
                   <a:srgbClr val="3B2A54"/>
                 </a:solidFill>
-                <a:latin typeface="DM Sans"/>
+                <a:latin typeface="Arial"/>
               </a:rPr>
               <a:t>Day 133 (1 Jan): </a:t>
             </a:r>
@@ -11502,7 +11491,7 @@
                 <a:solidFill>
                   <a:srgbClr val="3B2A54"/>
                 </a:solidFill>
-                <a:latin typeface="DM Sans"/>
+                <a:latin typeface="Arial"/>
               </a:rPr>
               <a:t>FY27 starts; $15M gate 1 opens to the vetted cases.</a:t>
             </a:r>
@@ -11537,7 +11526,7 @@
                 <a:solidFill>
                   <a:srgbClr val="3B2A54"/>
                 </a:solidFill>
-                <a:latin typeface="DM Sans"/>
+                <a:latin typeface="Arial"/>
               </a:rPr>
               <a:t>•</a:t>
             </a:r>
@@ -11572,7 +11561,7 @@
                 <a:solidFill>
                   <a:srgbClr val="3B2A54"/>
                 </a:solidFill>
-                <a:latin typeface="DM Sans"/>
+                <a:latin typeface="Arial"/>
               </a:rPr>
               <a:t>Day 150 (HQ D+90): </a:t>
             </a:r>
@@ -11581,7 +11570,7 @@
                 <a:solidFill>
                   <a:srgbClr val="3B2A54"/>
                 </a:solidFill>
-                <a:latin typeface="DM Sans"/>
+                <a:latin typeface="Arial"/>
               </a:rPr>
               <a:t>gate 3 cleared; Day-90 report to the CFO.</a:t>
             </a:r>
@@ -11616,7 +11605,7 @@
                 <a:solidFill>
                   <a:srgbClr val="3B2A54"/>
                 </a:solidFill>
-                <a:latin typeface="DM Sans"/>
+                <a:latin typeface="Arial"/>
               </a:rPr>
               <a:t>•</a:t>
             </a:r>
@@ -11651,7 +11640,7 @@
                 <a:solidFill>
                   <a:srgbClr val="3B2A54"/>
                 </a:solidFill>
-                <a:latin typeface="DM Sans"/>
+                <a:latin typeface="Arial"/>
               </a:rPr>
               <a:t>Beyond: </a:t>
             </a:r>
@@ -11660,7 +11649,7 @@
                 <a:solidFill>
                   <a:srgbClr val="3B2A54"/>
                 </a:solidFill>
-                <a:latin typeface="DM Sans"/>
+                <a:latin typeface="Arial"/>
               </a:rPr>
               <a:t>gate 2 at Q1 close (31 Mar); HQ gate 4 at D+120.</a:t>
             </a:r>
@@ -11695,7 +11684,7 @@
                 <a:solidFill>
                   <a:srgbClr val="6B5B82"/>
                 </a:solidFill>
-                <a:latin typeface="DM Sans"/>
+                <a:latin typeface="Arial"/>
               </a:rPr>
               <a:t>18</a:t>
             </a:r>
@@ -11800,7 +11789,7 @@
                 <a:solidFill>
                   <a:srgbClr val="820AD1"/>
                 </a:solidFill>
-                <a:latin typeface="DM Sans"/>
+                <a:latin typeface="Arial"/>
               </a:rPr>
               <a:t>SUPPORTING GOVERNANCE, EVIDENCE &amp; METHODOLOGY</a:t>
             </a:r>
@@ -11835,7 +11824,7 @@
                 <a:solidFill>
                   <a:srgbClr val="11052C"/>
                 </a:solidFill>
-                <a:latin typeface="Space Grotesk"/>
+                <a:latin typeface="Arial"/>
               </a:rPr>
               <a:t>Appendices &amp; Reference Ledger</a:t>
             </a:r>
@@ -11870,7 +11859,7 @@
                 <a:solidFill>
                   <a:srgbClr val="3B2A54"/>
                 </a:solidFill>
-                <a:latin typeface="DM Sans"/>
+                <a:latin typeface="Arial"/>
               </a:rPr>
               <a:t>Appendix A: Sources and assumptions ledger   |   Appendix B: Option scores and weight sensitivity</a:t>
             </a:r>
@@ -11905,7 +11894,7 @@
                 <a:solidFill>
                   <a:srgbClr val="6B5B82"/>
                 </a:solidFill>
-                <a:latin typeface="DM Sans"/>
+                <a:latin typeface="Arial"/>
               </a:rPr>
               <a:t>20</a:t>
             </a:r>
@@ -11991,7 +11980,7 @@
                           <a:solidFill>
                             <a:srgbClr val="FFFFFF"/>
                           </a:solidFill>
-                          <a:latin typeface="Space Grotesk"/>
+                          <a:latin typeface="Arial"/>
                         </a:rPr>
                         <a:t>Stage</a:t>
                       </a:r>
@@ -12026,7 +12015,7 @@
                           <a:solidFill>
                             <a:srgbClr val="FFFFFF"/>
                           </a:solidFill>
-                          <a:latin typeface="Space Grotesk"/>
+                          <a:latin typeface="Arial"/>
                         </a:rPr>
                         <a:t>Trigger for a local entity</a:t>
                       </a:r>
@@ -12061,7 +12050,7 @@
                           <a:solidFill>
                             <a:srgbClr val="FFFFFF"/>
                           </a:solidFill>
-                          <a:latin typeface="Space Grotesk"/>
+                          <a:latin typeface="Arial"/>
                         </a:rPr>
                         <a:t>Operating setup</a:t>
                       </a:r>
@@ -12096,7 +12085,7 @@
                           <a:solidFill>
                             <a:srgbClr val="FFFFFF"/>
                           </a:solidFill>
-                          <a:latin typeface="Space Grotesk"/>
+                          <a:latin typeface="Arial"/>
                         </a:rPr>
                         <a:t>Officers, signing and insurance</a:t>
                       </a:r>
@@ -12133,7 +12122,7 @@
                           <a:solidFill>
                             <a:srgbClr val="11052C"/>
                           </a:solidFill>
-                          <a:latin typeface="DM Sans"/>
+                          <a:latin typeface="Arial"/>
                         </a:rPr>
                         <a:t>1. Market test</a:t>
                       </a:r>
@@ -12142,7 +12131,7 @@
                           <a:solidFill>
                             <a:srgbClr val="11052C"/>
                           </a:solidFill>
-                          <a:latin typeface="DM Sans"/>
+                          <a:latin typeface="Arial"/>
                         </a:rPr>
                         <a:t> (new countries)</a:t>
                       </a:r>
@@ -12177,7 +12166,7 @@
                           <a:solidFill>
                             <a:srgbClr val="11052C"/>
                           </a:solidFill>
-                          <a:latin typeface="DM Sans"/>
+                          <a:latin typeface="Arial"/>
                         </a:rPr>
                         <a:t>No local license needed, no taxable presence created; served from an existing licensed entity or a partner bank.</a:t>
                       </a:r>
@@ -12212,7 +12201,7 @@
                           <a:solidFill>
                             <a:srgbClr val="11052C"/>
                           </a:solidFill>
-                          <a:latin typeface="DM Sans"/>
+                          <a:latin typeface="Arial"/>
                         </a:rPr>
                         <a:t>No local entity. Cross-border or partner model.</a:t>
                       </a:r>
@@ -12247,7 +12236,7 @@
                           <a:solidFill>
                             <a:srgbClr val="11052C"/>
                           </a:solidFill>
-                          <a:latin typeface="DM Sans"/>
+                          <a:latin typeface="Arial"/>
                         </a:rPr>
                         <a:t>Central signing only. No local director.</a:t>
                       </a:r>
@@ -12256,7 +12245,7 @@
                           <a:solidFill>
                             <a:srgbClr val="11052C"/>
                           </a:solidFill>
-                          <a:latin typeface="DM Sans"/>
+                          <a:latin typeface="Arial"/>
                         </a:rPr>
                         <a:t> Prevents an accidental permanent establishment.</a:t>
                       </a:r>
@@ -12293,7 +12282,7 @@
                           <a:solidFill>
                             <a:srgbClr val="11052C"/>
                           </a:solidFill>
-                          <a:latin typeface="DM Sans"/>
+                          <a:latin typeface="Arial"/>
                         </a:rPr>
                         <a:t>2. Licensed scale-up</a:t>
                       </a:r>
@@ -12302,7 +12291,7 @@
                           <a:solidFill>
                             <a:srgbClr val="11052C"/>
                           </a:solidFill>
-                          <a:latin typeface="DM Sans"/>
+                          <a:latin typeface="Arial"/>
                         </a:rPr>
                         <a:t> (US charter, new verticals)</a:t>
                       </a:r>
@@ -12337,7 +12326,7 @@
                           <a:solidFill>
                             <a:srgbClr val="11052C"/>
                           </a:solidFill>
-                          <a:latin typeface="DM Sans"/>
+                          <a:latin typeface="Arial"/>
                         </a:rPr>
                         <a:t>A regulator requires a local licensed entity (deposits, lending, custody), or substance rules require local payroll and assets.</a:t>
                       </a:r>
@@ -12372,7 +12361,7 @@
                           <a:solidFill>
                             <a:srgbClr val="11052C"/>
                           </a:solidFill>
-                          <a:latin typeface="DM Sans"/>
+                          <a:latin typeface="Arial"/>
                         </a:rPr>
                         <a:t>Dedicated licensed entity with its own capital plan and headroom.</a:t>
                       </a:r>
@@ -12407,7 +12396,7 @@
                           <a:solidFill>
                             <a:srgbClr val="11052C"/>
                           </a:solidFill>
-                          <a:latin typeface="DM Sans"/>
+                          <a:latin typeface="Arial"/>
                         </a:rPr>
                         <a:t>Fit-and-proper directors;</a:t>
                       </a:r>
@@ -12416,7 +12405,7 @@
                           <a:solidFill>
                             <a:srgbClr val="11052C"/>
                           </a:solidFill>
-                          <a:latin typeface="DM Sans"/>
+                          <a:latin typeface="Arial"/>
                         </a:rPr>
                         <a:t> two central officers plus one local leader; dual signature above a set limit; D&amp;O bound before activation.</a:t>
                       </a:r>
@@ -12453,7 +12442,7 @@
                           <a:solidFill>
                             <a:srgbClr val="11052C"/>
                           </a:solidFill>
-                          <a:latin typeface="DM Sans"/>
+                          <a:latin typeface="Arial"/>
                         </a:rPr>
                         <a:t>3. Core hub</a:t>
                       </a:r>
@@ -12462,7 +12451,7 @@
                           <a:solidFill>
                             <a:srgbClr val="11052C"/>
                           </a:solidFill>
-                          <a:latin typeface="DM Sans"/>
+                          <a:latin typeface="Arial"/>
                         </a:rPr>
                         <a:t> (Mexico as a bank since Aug 2026; Colombia; the HQ)</a:t>
                       </a:r>
@@ -12497,7 +12486,7 @@
                           <a:solidFill>
                             <a:srgbClr val="11052C"/>
                           </a:solidFill>
-                          <a:latin typeface="DM Sans"/>
+                          <a:latin typeface="Arial"/>
                         </a:rPr>
                         <a:t>Full banking or fintech license in force; local CFO in place (already so in Mexico and Colombia).</a:t>
                       </a:r>
@@ -12532,7 +12521,7 @@
                           <a:solidFill>
                             <a:srgbClr val="11052C"/>
                           </a:solidFill>
-                          <a:latin typeface="DM Sans"/>
+                          <a:latin typeface="Arial"/>
                         </a:rPr>
                         <a:t>Full licensed entity; regional campus where the HQ decision lands.</a:t>
                       </a:r>
@@ -12567,7 +12556,7 @@
                           <a:solidFill>
                             <a:srgbClr val="11052C"/>
                           </a:solidFill>
-                          <a:latin typeface="DM Sans"/>
+                          <a:latin typeface="Arial"/>
                         </a:rPr>
                         <a:t>Audit and Risk Committee oversight;</a:t>
                       </a:r>
@@ -12576,7 +12565,7 @@
                           <a:solidFill>
                             <a:srgbClr val="11052C"/>
                           </a:solidFill>
-                          <a:latin typeface="DM Sans"/>
+                          <a:latin typeface="Arial"/>
                         </a:rPr>
                         <a:t> dual signature above limits set by category; director liability insurance; annual review of powers of attorney.</a:t>
                       </a:r>
@@ -12633,7 +12622,7 @@
                 <a:solidFill>
                   <a:srgbClr val="820AD1"/>
                 </a:solidFill>
-                <a:latin typeface="DM Sans"/>
+                <a:latin typeface="Arial"/>
               </a:rPr>
               <a:t>13 // DELIVERABLE 2: STATUTORY GOVERNANCE ACROSS NEW ENTITIES</a:t>
             </a:r>
@@ -12672,7 +12661,7 @@
                 <a:solidFill>
                   <a:srgbClr val="11052C"/>
                 </a:solidFill>
-                <a:latin typeface="Space Grotesk"/>
+                <a:latin typeface="Arial"/>
               </a:rPr>
               <a:t>The model: open an entity only when a license or tax substance requires it; officers and signing follow the stage</a:t>
             </a:r>
@@ -12707,7 +12696,7 @@
                 <a:solidFill>
                   <a:srgbClr val="6B5B82"/>
                 </a:solidFill>
-                <a:latin typeface="DM Sans"/>
+                <a:latin typeface="Arial"/>
               </a:rPr>
               <a:t>Sources: Nu announcements (US launch via Lead Bank, 10 Sep 2026; OCC conditional approval, 29 Jan 2026; Mexico bank authorization, 10 Jul 2026; local finance leadership in Mexico and Colombia per the CFO appointment release). Signing limits are proposals (ASSUMPTION).</a:t>
             </a:r>
@@ -12742,7 +12731,7 @@
                 <a:solidFill>
                   <a:srgbClr val="6B5B82"/>
                 </a:solidFill>
-                <a:latin typeface="DM Sans"/>
+                <a:latin typeface="Arial"/>
               </a:rPr>
               <a:t>14</a:t>
             </a:r>
@@ -12828,7 +12817,7 @@
                           <a:solidFill>
                             <a:srgbClr val="FFFFFF"/>
                           </a:solidFill>
-                          <a:latin typeface="Space Grotesk"/>
+                          <a:latin typeface="Arial"/>
                         </a:rPr>
                         <a:t>Topic</a:t>
                       </a:r>
@@ -12863,7 +12852,7 @@
                           <a:solidFill>
                             <a:srgbClr val="FFFFFF"/>
                           </a:solidFill>
-                          <a:latin typeface="Space Grotesk"/>
+                          <a:latin typeface="Arial"/>
                         </a:rPr>
                         <a:t>Source and class</a:t>
                       </a:r>
@@ -12898,7 +12887,7 @@
                           <a:solidFill>
                             <a:srgbClr val="FFFFFF"/>
                           </a:solidFill>
-                          <a:latin typeface="Space Grotesk"/>
+                          <a:latin typeface="Arial"/>
                         </a:rPr>
                         <a:t>Data point</a:t>
                       </a:r>
@@ -12933,7 +12922,7 @@
                           <a:solidFill>
                             <a:srgbClr val="FFFFFF"/>
                           </a:solidFill>
-                          <a:latin typeface="Space Grotesk"/>
+                          <a:latin typeface="Arial"/>
                         </a:rPr>
                         <a:t>Where it is used</a:t>
                       </a:r>
@@ -12970,7 +12959,7 @@
                           <a:solidFill>
                             <a:srgbClr val="11052C"/>
                           </a:solidFill>
-                          <a:latin typeface="DM Sans"/>
+                          <a:latin typeface="Arial"/>
                         </a:rPr>
                         <a:t>1. Nu scale and efficiency</a:t>
                       </a:r>
@@ -13005,7 +12994,7 @@
                           <a:solidFill>
                             <a:srgbClr val="11052C"/>
                           </a:solidFill>
-                          <a:latin typeface="DM Sans"/>
+                          <a:latin typeface="Arial"/>
                         </a:rPr>
                         <a:t>Nu Q2'26 release and 6-K; 20-F</a:t>
                       </a:r>
@@ -13014,7 +13003,7 @@
                           <a:solidFill>
                             <a:srgbClr val="11052C"/>
                           </a:solidFill>
-                          <a:latin typeface="DM Sans"/>
+                          <a:latin typeface="Arial"/>
                         </a:rPr>
                         <a:t> | FACT</a:t>
                       </a:r>
@@ -13049,7 +13038,7 @@
                           <a:solidFill>
                             <a:srgbClr val="11052C"/>
                           </a:solidFill>
-                          <a:latin typeface="DM Sans"/>
+                          <a:latin typeface="Arial"/>
                         </a:rPr>
                         <a:t>138.9M customers; ARPAC $17.1; cost to serve $1.0; efficiency ratio 19.5% (FY26 ~20% per the call); ROE 33%; net income $1.06B; low-and-grow underwriting.</a:t>
                       </a:r>
@@ -13084,7 +13073,7 @@
                           <a:solidFill>
                             <a:srgbClr val="11052C"/>
                           </a:solidFill>
-                          <a:latin typeface="DM Sans"/>
+                          <a:latin typeface="Arial"/>
                         </a:rPr>
                         <a:t>Slides 4, 5, 8, 10, 17: the cap, the planning principle, the 70/30 release.</a:t>
                       </a:r>
@@ -13121,7 +13110,7 @@
                           <a:solidFill>
                             <a:srgbClr val="11052C"/>
                           </a:solidFill>
-                          <a:latin typeface="DM Sans"/>
+                          <a:latin typeface="Arial"/>
                         </a:rPr>
                         <a:t>2. Corporate events</a:t>
                       </a:r>
@@ -13156,7 +13145,7 @@
                           <a:solidFill>
                             <a:srgbClr val="11052C"/>
                           </a:solidFill>
-                          <a:latin typeface="DM Sans"/>
+                          <a:latin typeface="Arial"/>
                         </a:rPr>
                         <a:t>Nu announcements; OCC; Nu IR</a:t>
                       </a:r>
@@ -13165,7 +13154,7 @@
                           <a:solidFill>
                             <a:srgbClr val="11052C"/>
                           </a:solidFill>
-                          <a:latin typeface="DM Sans"/>
+                          <a:latin typeface="Arial"/>
                         </a:rPr>
                         <a:t> | FACT</a:t>
                       </a:r>
@@ -13200,7 +13189,7 @@
                           <a:solidFill>
                             <a:srgbClr val="11052C"/>
                           </a:solidFill>
-                          <a:latin typeface="DM Sans"/>
+                          <a:latin typeface="Arial"/>
                         </a:rPr>
                         <a:t>Mexico bank authorization 10 Jul 2026 (bank operations from 6 Aug), $4.2B plan to 2030; OCC conditional approval 29 Jan 2026 (capitalize within 12 months); US launch via Lead Bank 10 Sep 2026; buyback up to $1.0B (4 Jun 2026); CFO since 13 Jul 2026; Q3'26 results 12 Nov 2026; Investor Day 8 Dec 2026.</a:t>
                       </a:r>
@@ -13235,7 +13224,7 @@
                           <a:solidFill>
                             <a:srgbClr val="11052C"/>
                           </a:solidFill>
-                          <a:latin typeface="DM Sans"/>
+                          <a:latin typeface="Arial"/>
                         </a:rPr>
                         <a:t>Slides 12, 13, 14: the capital question and the Board calendar.</a:t>
                       </a:r>
@@ -13272,7 +13261,7 @@
                           <a:solidFill>
                             <a:srgbClr val="11052C"/>
                           </a:solidFill>
-                          <a:latin typeface="DM Sans"/>
+                          <a:latin typeface="Arial"/>
                         </a:rPr>
                         <a:t>3. HQ tax rules</a:t>
                       </a:r>
@@ -13307,7 +13296,7 @@
                           <a:solidFill>
                             <a:srgbClr val="11052C"/>
                           </a:solidFill>
-                          <a:latin typeface="DM Sans"/>
+                          <a:latin typeface="Arial"/>
                         </a:rPr>
                         <a:t>OECD GloBE Model Rules</a:t>
                       </a:r>
@@ -13316,7 +13305,7 @@
                           <a:solidFill>
                             <a:srgbClr val="11052C"/>
                           </a:solidFill>
-                          <a:latin typeface="DM Sans"/>
+                          <a:latin typeface="Arial"/>
                         </a:rPr>
                         <a:t> | FACT (rule); ASSUMPTION (site)</a:t>
                       </a:r>
@@ -13351,7 +13340,7 @@
                           <a:solidFill>
                             <a:srgbClr val="11052C"/>
                           </a:solidFill>
-                          <a:latin typeface="DM Sans"/>
+                          <a:latin typeface="Arial"/>
                         </a:rPr>
                         <a:t>EUR 750M threshold; 15% minimum; 2026 transitional carve-out 9.4% of payroll and 7.4% of tangible assets (Art. 9.2).</a:t>
                       </a:r>
@@ -13386,7 +13375,7 @@
                           <a:solidFill>
                             <a:srgbClr val="11052C"/>
                           </a:solidFill>
-                          <a:latin typeface="DM Sans"/>
+                          <a:latin typeface="Arial"/>
                         </a:rPr>
                         <a:t>Slide 15, gate 1. No savings figure is claimed before a site is chosen.</a:t>
                       </a:r>
@@ -13423,7 +13412,7 @@
                           <a:solidFill>
                             <a:srgbClr val="11052C"/>
                           </a:solidFill>
-                          <a:latin typeface="DM Sans"/>
+                          <a:latin typeface="Arial"/>
                         </a:rPr>
                         <a:t>4. Directional benchmarks</a:t>
                       </a:r>
@@ -13458,7 +13447,7 @@
                           <a:solidFill>
                             <a:srgbClr val="11052C"/>
                           </a:solidFill>
-                          <a:latin typeface="DM Sans"/>
+                          <a:latin typeface="Arial"/>
                         </a:rPr>
                         <a:t>Hackett, McKinsey, Gartner, HBR, NACD, Deloitte</a:t>
                       </a:r>
@@ -13467,7 +13456,7 @@
                           <a:solidFill>
                             <a:srgbClr val="11052C"/>
                           </a:solidFill>
-                          <a:latin typeface="DM Sans"/>
+                          <a:latin typeface="Arial"/>
                         </a:rPr>
                         <a:t> | CONTEXT, not load-bearing</a:t>
                       </a:r>
@@ -13502,7 +13491,7 @@
                           <a:solidFill>
                             <a:srgbClr val="11052C"/>
                           </a:solidFill>
-                          <a:latin typeface="DM Sans"/>
+                          <a:latin typeface="Arial"/>
                         </a:rPr>
                         <a:t>Central hubs shorten planning cycles; active reallocators earn higher returns; fair process wins acceptance; T-7 Board books shift meeting time to strategy.</a:t>
                       </a:r>
@@ -13537,7 +13526,7 @@
                           <a:solidFill>
                             <a:srgbClr val="11052C"/>
                           </a:solidFill>
-                          <a:latin typeface="DM Sans"/>
+                          <a:latin typeface="Arial"/>
                         </a:rPr>
                         <a:t>Named in footers only. No headline rests on them.</a:t>
                       </a:r>
@@ -13594,7 +13583,7 @@
                 <a:solidFill>
                   <a:srgbClr val="820AD1"/>
                 </a:solidFill>
-                <a:latin typeface="DM Sans"/>
+                <a:latin typeface="Arial"/>
               </a:rPr>
               <a:t>APPENDIX A // SOURCES AND ASSUMPTIONS LEDGER</a:t>
             </a:r>
@@ -13633,7 +13622,7 @@
                 <a:solidFill>
                   <a:srgbClr val="11052C"/>
                 </a:solidFill>
-                <a:latin typeface="Space Grotesk"/>
+                <a:latin typeface="Arial"/>
               </a:rPr>
               <a:t>Every number in the deck is a sourced fact, a labeled assumption, or a directional benchmark that carries no weight</a:t>
             </a:r>
@@ -13668,7 +13657,7 @@
                 <a:solidFill>
                   <a:srgbClr val="6B5B82"/>
                 </a:solidFill>
-                <a:latin typeface="DM Sans"/>
+                <a:latin typeface="Arial"/>
               </a:rPr>
               <a:t>My assumptions (A3-A6, A9, A10) are on slide 3 with their basis. Research assisted by AI tools; every figure, calculation and recommendation was checked by me.</a:t>
             </a:r>
@@ -13703,7 +13692,7 @@
                 <a:solidFill>
                   <a:srgbClr val="6B5B82"/>
                 </a:solidFill>
-                <a:latin typeface="DM Sans"/>
+                <a:latin typeface="Arial"/>
               </a:rPr>
               <a:t>21</a:t>
             </a:r>
@@ -14002,7 +13991,7 @@
                 <a:solidFill>
                   <a:srgbClr val="820AD1"/>
                 </a:solidFill>
-                <a:latin typeface="DM Sans"/>
+                <a:latin typeface="Arial"/>
               </a:rPr>
               <a:t>01 // EXECUTIVE SUMMARY &amp; CORE RECOMMENDATION</a:t>
             </a:r>
@@ -14041,7 +14030,7 @@
                 <a:solidFill>
                   <a:srgbClr val="11052C"/>
                 </a:solidFill>
-                <a:latin typeface="Space Grotesk"/>
+                <a:latin typeface="Arial"/>
               </a:rPr>
               <a:t>Fund FY27's $25M through two business-case gates, lock the Board plan 16 days out, and charter the HQ project this week</a:t>
             </a:r>
@@ -14076,7 +14065,7 @@
                 <a:solidFill>
                   <a:srgbClr val="820AD1"/>
                 </a:solidFill>
-                <a:latin typeface="DM Sans"/>
+                <a:latin typeface="Arial"/>
               </a:rPr>
               <a:t>DELIVERABLE 1 // PLANNING</a:t>
             </a:r>
@@ -14111,7 +14100,7 @@
                 <a:solidFill>
                   <a:srgbClr val="11052C"/>
                 </a:solidFill>
-                <a:latin typeface="Space Grotesk"/>
+                <a:latin typeface="Arial"/>
               </a:rPr>
               <a:t>$25M in two gates</a:t>
             </a:r>
@@ -14146,7 +14135,7 @@
                 <a:solidFill>
                   <a:srgbClr val="3B2A54"/>
                 </a:solidFill>
-                <a:latin typeface="DM Sans"/>
+                <a:latin typeface="Arial"/>
               </a:rPr>
               <a:t>Every ask gets a business case; $15M at FY27 start, $10M at Q1 close on indicators. No flat haircuts.</a:t>
             </a:r>
@@ -14181,7 +14170,7 @@
                 <a:solidFill>
                   <a:srgbClr val="820AD1"/>
                 </a:solidFill>
-                <a:latin typeface="DM Sans"/>
+                <a:latin typeface="Arial"/>
               </a:rPr>
               <a:t>DELIVERABLE 2 // BOARD</a:t>
             </a:r>
@@ -14216,7 +14205,7 @@
                 <a:solidFill>
                   <a:srgbClr val="11052C"/>
                 </a:solidFill>
-                <a:latin typeface="Space Grotesk"/>
+                <a:latin typeface="Arial"/>
               </a:rPr>
               <a:t>T-16 lock, T-7 book</a:t>
             </a:r>
@@ -14251,7 +14240,7 @@
                 <a:solidFill>
                   <a:srgbClr val="3B2A54"/>
                 </a:solidFill>
-                <a:latin typeface="DM Sans"/>
+                <a:latin typeface="Arial"/>
               </a:rPr>
               <a:t>One options memo settles the capital dispute at T-16; the Board book ships at T-7 with written Q&amp;A.</a:t>
             </a:r>
@@ -14286,7 +14275,7 @@
                 <a:solidFill>
                   <a:srgbClr val="820AD1"/>
                 </a:solidFill>
-                <a:latin typeface="DM Sans"/>
+                <a:latin typeface="Arial"/>
               </a:rPr>
               <a:t>DELIVERABLE 3 // HQ PROJECT</a:t>
             </a:r>
@@ -14321,7 +14310,7 @@
                 <a:solidFill>
                   <a:srgbClr val="11052C"/>
                 </a:solidFill>
-                <a:latin typeface="Space Grotesk"/>
+                <a:latin typeface="Arial"/>
               </a:rPr>
               <a:t>4 gates, 120 days</a:t>
             </a:r>
@@ -14356,7 +14345,7 @@
                 <a:solidFill>
                   <a:srgbClr val="3B2A54"/>
                 </a:solidFill>
-                <a:latin typeface="DM Sans"/>
+                <a:latin typeface="Arial"/>
               </a:rPr>
               <a:t>Tax substance, grant terms, officer liability and lease, each with an owner and an exit test.</a:t>
             </a:r>
@@ -14391,7 +14380,7 @@
                 <a:solidFill>
                   <a:srgbClr val="820AD1"/>
                 </a:solidFill>
-                <a:latin typeface="DM Sans"/>
+                <a:latin typeface="Arial"/>
               </a:rPr>
               <a:t>DELIVERABLE 4 // LEADERSHIP</a:t>
             </a:r>
@@ -14426,7 +14415,7 @@
                 <a:solidFill>
                   <a:srgbClr val="11052C"/>
                 </a:solidFill>
-                <a:latin typeface="Space Grotesk"/>
+                <a:latin typeface="Arial"/>
               </a:rPr>
               <a:t>Rigor in the squads</a:t>
             </a:r>
@@ -14461,7 +14450,7 @@
                 <a:solidFill>
                   <a:srgbClr val="3B2A54"/>
                 </a:solidFill>
-                <a:latin typeface="DM Sans"/>
+                <a:latin typeface="Arial"/>
               </a:rPr>
               <a:t>I work inside the business units with the numbers, not above them with a veto.</a:t>
             </a:r>
@@ -14496,7 +14485,7 @@
                 <a:solidFill>
                   <a:srgbClr val="C084FC"/>
                 </a:solidFill>
-                <a:latin typeface="DM Sans"/>
+                <a:latin typeface="Arial"/>
               </a:rPr>
               <a:t>THE ASK</a:t>
             </a:r>
@@ -14531,7 +14520,7 @@
                 <a:solidFill>
                   <a:srgbClr val="FFFFFF"/>
                 </a:solidFill>
-                <a:latin typeface="DM Sans"/>
+                <a:latin typeface="Arial"/>
               </a:rPr>
               <a:t>Approve the $25M FY27 cap in two gates, with a CFO- and IR-gated valve of up to $15M that is not in plan; the T-16 / T-7 Board calendar; and the HQ project charter. I report on all three at Day 90.</a:t>
             </a:r>
@@ -14566,7 +14555,7 @@
                 <a:solidFill>
                   <a:srgbClr val="6B5B82"/>
                 </a:solidFill>
-                <a:latin typeface="DM Sans"/>
+                <a:latin typeface="Arial"/>
               </a:rPr>
               <a:t>2</a:t>
             </a:r>
@@ -14671,7 +14660,7 @@
                 <a:solidFill>
                   <a:srgbClr val="C084FC"/>
                 </a:solidFill>
-                <a:latin typeface="DM Sans"/>
+                <a:latin typeface="Arial"/>
               </a:rPr>
               <a:t>NU HOLDINGS LTD. // OFFICE OF THE CFO &amp; CORPORATE GOVERNANCE</a:t>
             </a:r>
@@ -14710,7 +14699,7 @@
                 <a:solidFill>
                   <a:srgbClr val="FFFFFF"/>
                 </a:solidFill>
-                <a:latin typeface="Space Grotesk"/>
+                <a:latin typeface="Arial"/>
               </a:rPr>
               <a:t>The ask: approve the $25M FY27 cap in two gates with the A6 valve stated, the T-16 / T-7 Board calendar, and the HQ charter. I report back at Day 90.</a:t>
             </a:r>
@@ -14745,7 +14734,7 @@
                 <a:solidFill>
                   <a:srgbClr val="E9D5FF"/>
                 </a:solidFill>
-                <a:latin typeface="DM Sans"/>
+                <a:latin typeface="Arial"/>
               </a:rPr>
               <a:t>KPIs at Day 90: 100% of gate-1 spend with an approved case; Board book at T-7; HQ gates 1 and 2 cleared. Stop rules: two of four indicators below plan, or the efficiency ratio above the FY26 guide.</a:t>
             </a:r>
@@ -14780,7 +14769,7 @@
                 <a:solidFill>
                   <a:srgbClr val="C084FC"/>
                 </a:solidFill>
-                <a:latin typeface="DM Sans"/>
+                <a:latin typeface="Arial"/>
               </a:rPr>
               <a:t>19</a:t>
             </a:r>
@@ -14866,7 +14855,7 @@
                           <a:solidFill>
                             <a:srgbClr val="FFFFFF"/>
                           </a:solidFill>
-                          <a:latin typeface="Space Grotesk"/>
+                          <a:latin typeface="Arial"/>
                         </a:rPr>
                         <a:t>#</a:t>
                       </a:r>
@@ -14901,7 +14890,7 @@
                           <a:solidFill>
                             <a:srgbClr val="FFFFFF"/>
                           </a:solidFill>
-                          <a:latin typeface="Space Grotesk"/>
+                          <a:latin typeface="Arial"/>
                         </a:rPr>
                         <a:t>Assumption or fact</a:t>
                       </a:r>
@@ -14936,7 +14925,7 @@
                           <a:solidFill>
                             <a:srgbClr val="FFFFFF"/>
                           </a:solidFill>
-                          <a:latin typeface="Space Grotesk"/>
+                          <a:latin typeface="Arial"/>
                         </a:rPr>
                         <a:t>Class</a:t>
                       </a:r>
@@ -14971,7 +14960,7 @@
                           <a:solidFill>
                             <a:srgbClr val="FFFFFF"/>
                           </a:solidFill>
-                          <a:latin typeface="Space Grotesk"/>
+                          <a:latin typeface="Arial"/>
                         </a:rPr>
                         <a:t>Basis</a:t>
                       </a:r>
@@ -15008,7 +14997,7 @@
                           <a:solidFill>
                             <a:srgbClr val="11052C"/>
                           </a:solidFill>
-                          <a:latin typeface="DM Sans"/>
+                          <a:latin typeface="Arial"/>
                         </a:rPr>
                         <a:t>A1</a:t>
                       </a:r>
@@ -15043,7 +15032,7 @@
                           <a:solidFill>
                             <a:srgbClr val="11052C"/>
                           </a:solidFill>
-                          <a:latin typeface="DM Sans"/>
+                          <a:latin typeface="Arial"/>
                         </a:rPr>
                         <a:t>Nu Q2'26: 138.9M customers, monthly ARPAC $17.1, cost to serve $1.0, efficiency ratio 19.5%, ROE 33%, net income $1.06B.</a:t>
                       </a:r>
@@ -15078,7 +15067,7 @@
                           <a:solidFill>
                             <a:srgbClr val="11052C"/>
                           </a:solidFill>
-                          <a:latin typeface="DM Sans"/>
+                          <a:latin typeface="Arial"/>
                         </a:rPr>
                         <a:t>FACT</a:t>
                       </a:r>
@@ -15113,7 +15102,7 @@
                           <a:solidFill>
                             <a:srgbClr val="11052C"/>
                           </a:solidFill>
-                          <a:latin typeface="DM Sans"/>
+                          <a:latin typeface="Arial"/>
                         </a:rPr>
                         <a:t>Q2'26 earnings release and 6-K</a:t>
                       </a:r>
@@ -15150,7 +15139,7 @@
                           <a:solidFill>
                             <a:srgbClr val="11052C"/>
                           </a:solidFill>
-                          <a:latin typeface="DM Sans"/>
+                          <a:latin typeface="Arial"/>
                         </a:rPr>
                         <a:t>A2</a:t>
                       </a:r>
@@ -15185,7 +15174,7 @@
                           <a:solidFill>
                             <a:srgbClr val="11052C"/>
                           </a:solidFill>
-                          <a:latin typeface="DM Sans"/>
+                          <a:latin typeface="Arial"/>
                         </a:rPr>
                         <a:t>Management expects the FY26 efficiency ratio near 20% and guided US spend at no more than about 100 bps of it.</a:t>
                       </a:r>
@@ -15220,7 +15209,7 @@
                           <a:solidFill>
                             <a:srgbClr val="11052C"/>
                           </a:solidFill>
-                          <a:latin typeface="DM Sans"/>
+                          <a:latin typeface="Arial"/>
                         </a:rPr>
                         <a:t>FACT (wording to re-check)</a:t>
                       </a:r>
@@ -15255,7 +15244,7 @@
                           <a:solidFill>
                             <a:srgbClr val="11052C"/>
                           </a:solidFill>
-                          <a:latin typeface="DM Sans"/>
+                          <a:latin typeface="Arial"/>
                         </a:rPr>
                         <a:t>Q2'26 earnings call</a:t>
                       </a:r>
@@ -15292,7 +15281,7 @@
                           <a:solidFill>
                             <a:srgbClr val="11052C"/>
                           </a:solidFill>
-                          <a:latin typeface="DM Sans"/>
+                          <a:latin typeface="Arial"/>
                         </a:rPr>
                         <a:t>A3</a:t>
                       </a:r>
@@ -15327,7 +15316,7 @@
                           <a:solidFill>
                             <a:srgbClr val="11052C"/>
                           </a:solidFill>
-                          <a:latin typeface="DM Sans"/>
+                          <a:latin typeface="Arial"/>
                         </a:rPr>
                         <a:t>The $60M asks and the $25M cap are the case's figures. At Nu's scale $35M is about 15 bps of annualized revenue; the stakes are the operating model and the precedent, not the amount.</a:t>
                       </a:r>
@@ -15362,7 +15351,7 @@
                           <a:solidFill>
                             <a:srgbClr val="11052C"/>
                           </a:solidFill>
-                          <a:latin typeface="DM Sans"/>
+                          <a:latin typeface="Arial"/>
                         </a:rPr>
                         <a:t>ASSUMPTION</a:t>
                       </a:r>
@@ -15397,7 +15386,7 @@
                           <a:solidFill>
                             <a:srgbClr val="11052C"/>
                           </a:solidFill>
-                          <a:latin typeface="DM Sans"/>
+                          <a:latin typeface="Arial"/>
                         </a:rPr>
                         <a:t>Case brief; my calculation on Q2'26 revenue</a:t>
                       </a:r>
@@ -15434,7 +15423,7 @@
                           <a:solidFill>
                             <a:srgbClr val="11052C"/>
                           </a:solidFill>
-                          <a:latin typeface="DM Sans"/>
+                          <a:latin typeface="Arial"/>
                         </a:rPr>
                         <a:t>A4</a:t>
                       </a:r>
@@ -15469,7 +15458,7 @@
                           <a:solidFill>
                             <a:srgbClr val="11052C"/>
                           </a:solidFill>
-                          <a:latin typeface="DM Sans"/>
+                          <a:latin typeface="Arial"/>
                         </a:rPr>
                         <a:t>The two MTeam members disagree about the growth-opex envelope (core markets vs new bets), not about regulatory capital by entity.</a:t>
                       </a:r>
@@ -15504,7 +15493,7 @@
                           <a:solidFill>
                             <a:srgbClr val="11052C"/>
                           </a:solidFill>
-                          <a:latin typeface="DM Sans"/>
+                          <a:latin typeface="Arial"/>
                         </a:rPr>
                         <a:t>ASSUMPTION</a:t>
                       </a:r>
@@ -15539,7 +15528,7 @@
                           <a:solidFill>
                             <a:srgbClr val="11052C"/>
                           </a:solidFill>
-                          <a:latin typeface="DM Sans"/>
+                          <a:latin typeface="Arial"/>
                         </a:rPr>
                         <a:t>Case brief is silent; verify in week one</a:t>
                       </a:r>
@@ -15576,7 +15565,7 @@
                           <a:solidFill>
                             <a:srgbClr val="11052C"/>
                           </a:solidFill>
-                          <a:latin typeface="DM Sans"/>
+                          <a:latin typeface="Arial"/>
                         </a:rPr>
                         <a:t>A5</a:t>
                       </a:r>
@@ -15611,7 +15600,7 @@
                           <a:solidFill>
                             <a:srgbClr val="11052C"/>
                           </a:solidFill>
-                          <a:latin typeface="DM Sans"/>
+                          <a:latin typeface="Arial"/>
                         </a:rPr>
                         <a:t>$8M of the asks can be met on the shared global platform at near-zero marginal cost; $12M lack a business case today and can be prepared in 60 days.</a:t>
                       </a:r>
@@ -15646,7 +15635,7 @@
                           <a:solidFill>
                             <a:srgbClr val="820AD1"/>
                           </a:solidFill>
-                          <a:latin typeface="DM Sans"/>
+                          <a:latin typeface="Arial"/>
                         </a:rPr>
                         <a:t>ASSUMPTION</a:t>
                       </a:r>
@@ -15681,7 +15670,7 @@
                           <a:solidFill>
                             <a:srgbClr val="11052C"/>
                           </a:solidFill>
-                          <a:latin typeface="DM Sans"/>
+                          <a:latin typeface="Arial"/>
                         </a:rPr>
                         <a:t>My estimate; verify with Engineering and the GMs</a:t>
                       </a:r>
@@ -15718,7 +15707,7 @@
                           <a:solidFill>
                             <a:srgbClr val="11052C"/>
                           </a:solidFill>
-                          <a:latin typeface="DM Sans"/>
+                          <a:latin typeface="Arial"/>
                         </a:rPr>
                         <a:t>A6</a:t>
                       </a:r>
@@ -15753,7 +15742,7 @@
                           <a:solidFill>
                             <a:srgbClr val="11052C"/>
                           </a:solidFill>
-                          <a:latin typeface="DM Sans"/>
+                          <a:latin typeface="Arial"/>
                         </a:rPr>
                         <a:t>Any spend above $25M is released only from H1 profit above plan, sized so the efficiency ratio stays inside the FY26 guide, and only with CFO and IR agreement.</a:t>
                       </a:r>
@@ -15788,7 +15777,7 @@
                           <a:solidFill>
                             <a:srgbClr val="820AD1"/>
                           </a:solidFill>
-                          <a:latin typeface="DM Sans"/>
+                          <a:latin typeface="Arial"/>
                         </a:rPr>
                         <a:t>RULE (proposed)</a:t>
                       </a:r>
@@ -15823,7 +15812,7 @@
                           <a:solidFill>
                             <a:srgbClr val="11052C"/>
                           </a:solidFill>
-                          <a:latin typeface="DM Sans"/>
+                          <a:latin typeface="Arial"/>
                         </a:rPr>
                         <a:t>To agree with the CFO</a:t>
                       </a:r>
@@ -15860,7 +15849,7 @@
                           <a:solidFill>
                             <a:srgbClr val="11052C"/>
                           </a:solidFill>
-                          <a:latin typeface="DM Sans"/>
+                          <a:latin typeface="Arial"/>
                         </a:rPr>
                         <a:t>A7</a:t>
                       </a:r>
@@ -15895,7 +15884,7 @@
                           <a:solidFill>
                             <a:srgbClr val="11052C"/>
                           </a:solidFill>
-                          <a:latin typeface="DM Sans"/>
+                          <a:latin typeface="Arial"/>
                         </a:rPr>
                         <a:t>Board meeting in 4 weeks; Investor Day 8 Dec 2026. The Board approves the international capital plan before the Investor Day narrative is locked.</a:t>
                       </a:r>
@@ -15930,7 +15919,7 @@
                           <a:solidFill>
                             <a:srgbClr val="820AD1"/>
                           </a:solidFill>
-                          <a:latin typeface="DM Sans"/>
+                          <a:latin typeface="Arial"/>
                         </a:rPr>
                         <a:t>FACT (dates) + ASSUMPTION (sequence)</a:t>
                       </a:r>
@@ -15965,7 +15954,7 @@
                           <a:solidFill>
                             <a:srgbClr val="11052C"/>
                           </a:solidFill>
-                          <a:latin typeface="DM Sans"/>
+                          <a:latin typeface="Arial"/>
                         </a:rPr>
                         <a:t>Case brief; Nu IR</a:t>
                       </a:r>
@@ -16002,7 +15991,7 @@
                           <a:solidFill>
                             <a:srgbClr val="11052C"/>
                           </a:solidFill>
-                          <a:latin typeface="DM Sans"/>
+                          <a:latin typeface="Arial"/>
                         </a:rPr>
                         <a:t>A8</a:t>
                       </a:r>
@@ -16037,7 +16026,7 @@
                           <a:solidFill>
                             <a:srgbClr val="11052C"/>
                           </a:solidFill>
-                          <a:latin typeface="DM Sans"/>
+                          <a:latin typeface="Arial"/>
                         </a:rPr>
                         <a:t>The HQ jurisdiction is open. Nu's revenue is above the EUR 750M Pillar Two threshold; the 2026 transitional substance carve-out is 9.4% of payroll and 7.4% of tangible assets.</a:t>
                       </a:r>
@@ -16072,7 +16061,7 @@
                           <a:solidFill>
                             <a:srgbClr val="820AD1"/>
                           </a:solidFill>
-                          <a:latin typeface="DM Sans"/>
+                          <a:latin typeface="Arial"/>
                         </a:rPr>
                         <a:t>FACT (rule) + ASSUMPTION (site)</a:t>
                       </a:r>
@@ -16107,7 +16096,7 @@
                           <a:solidFill>
                             <a:srgbClr val="11052C"/>
                           </a:solidFill>
-                          <a:latin typeface="DM Sans"/>
+                          <a:latin typeface="Arial"/>
                         </a:rPr>
                         <a:t>OECD GloBE rules; Q2'26 revenue</a:t>
                       </a:r>
@@ -16144,7 +16133,7 @@
                           <a:solidFill>
                             <a:srgbClr val="11052C"/>
                           </a:solidFill>
-                          <a:latin typeface="DM Sans"/>
+                          <a:latin typeface="Arial"/>
                         </a:rPr>
                         <a:t>A9</a:t>
                       </a:r>
@@ -16179,7 +16168,7 @@
                           <a:solidFill>
                             <a:srgbClr val="11052C"/>
                           </a:solidFill>
-                          <a:latin typeface="DM Sans"/>
+                          <a:latin typeface="Arial"/>
                         </a:rPr>
                         <a:t>Option scores and weights on slide 6 are my judgment; third-party benchmarks are directional, never load-bearing.</a:t>
                       </a:r>
@@ -16214,7 +16203,7 @@
                           <a:solidFill>
                             <a:srgbClr val="820AD1"/>
                           </a:solidFill>
-                          <a:latin typeface="DM Sans"/>
+                          <a:latin typeface="Arial"/>
                         </a:rPr>
                         <a:t>ASSUMPTION</a:t>
                       </a:r>
@@ -16249,7 +16238,7 @@
                           <a:solidFill>
                             <a:srgbClr val="11052C"/>
                           </a:solidFill>
-                          <a:latin typeface="DM Sans"/>
+                          <a:latin typeface="Arial"/>
                         </a:rPr>
                         <a:t>Slide 6; ledger</a:t>
                       </a:r>
@@ -16286,7 +16275,7 @@
                           <a:solidFill>
                             <a:srgbClr val="11052C"/>
                           </a:solidFill>
-                          <a:latin typeface="DM Sans"/>
+                          <a:latin typeface="Arial"/>
                         </a:rPr>
                         <a:t>A10</a:t>
                       </a:r>
@@ -16321,7 +16310,7 @@
                           <a:solidFill>
                             <a:srgbClr val="11052C"/>
                           </a:solidFill>
-                          <a:latin typeface="DM Sans"/>
+                          <a:latin typeface="Arial"/>
                         </a:rPr>
                         <a:t>The cap is the FY27 growth-opex envelope: gate 1 opens at FY27 start (1 Jan 2027), gate 2 at Q1 close (31 Mar) on Q1 indicators, the A6 valve at H1 close. The hub needs 6-8 people.</a:t>
                       </a:r>
@@ -16356,7 +16345,7 @@
                           <a:solidFill>
                             <a:srgbClr val="820AD1"/>
                           </a:solidFill>
-                          <a:latin typeface="DM Sans"/>
+                          <a:latin typeface="Arial"/>
                         </a:rPr>
                         <a:t>ASSUMPTION (fiscal calendar, sizing)</a:t>
                       </a:r>
@@ -16391,7 +16380,7 @@
                           <a:solidFill>
                             <a:srgbClr val="11052C"/>
                           </a:solidFill>
-                          <a:latin typeface="DM Sans"/>
+                          <a:latin typeface="Arial"/>
                         </a:rPr>
                         <a:t>Nu reports on a calendar fiscal year; sizing is mine</a:t>
                       </a:r>
@@ -16448,7 +16437,7 @@
                 <a:solidFill>
                   <a:srgbClr val="820AD1"/>
                 </a:solidFill>
-                <a:latin typeface="DM Sans"/>
+                <a:latin typeface="Arial"/>
               </a:rPr>
               <a:t>02 // WHAT I AM ASSUMING, AND WHAT I WOULD VERIFY IN WEEK ONE</a:t>
             </a:r>
@@ -16487,7 +16476,7 @@
                 <a:solidFill>
                   <a:srgbClr val="11052C"/>
                 </a:solidFill>
-                <a:latin typeface="Space Grotesk"/>
+                <a:latin typeface="Arial"/>
               </a:rPr>
               <a:t>Key assumptions, separated from the facts they sit on</a:t>
             </a:r>
@@ -16522,7 +16511,7 @@
                 <a:solidFill>
                   <a:srgbClr val="3B2A54"/>
                 </a:solidFill>
-                <a:latin typeface="DM Sans"/>
+                <a:latin typeface="Arial"/>
               </a:rPr>
               <a:t>Week one: </a:t>
             </a:r>
@@ -16531,7 +16520,7 @@
                 <a:solidFill>
                   <a:srgbClr val="3B2A54"/>
                 </a:solidFill>
-                <a:latin typeface="DM Sans"/>
+                <a:latin typeface="Arial"/>
               </a:rPr>
               <a:t>the real MTeam positions; the Board and committee calendar; who owns the planning model today; local-CFO decision rights in Mexico and Colombia; the HQ project's current state; today's planning cycle time and forecast accuracy.</a:t>
             </a:r>
@@ -16566,7 +16555,7 @@
                 <a:solidFill>
                   <a:srgbClr val="6B5B82"/>
                 </a:solidFill>
-                <a:latin typeface="DM Sans"/>
+                <a:latin typeface="Arial"/>
               </a:rPr>
               <a:t>3</a:t>
             </a:r>
@@ -16771,7 +16760,7 @@
                 <a:solidFill>
                   <a:srgbClr val="820AD1"/>
                 </a:solidFill>
-                <a:latin typeface="DM Sans"/>
+                <a:latin typeface="Arial"/>
               </a:rPr>
               <a:t>11 // DELIVERABLE 2: THE CAPITAL QUESTION THE BOARD WILL ACTUALLY ASK</a:t>
             </a:r>
@@ -16810,7 +16799,7 @@
                 <a:solidFill>
                   <a:srgbClr val="11052C"/>
                 </a:solidFill>
-                <a:latin typeface="Space Grotesk"/>
+                <a:latin typeface="Arial"/>
               </a:rPr>
               <a:t>Equity by entity is the Board's larger decision than the opex cap; it gets its own ranking, yardstick and owner</a:t>
             </a:r>
@@ -16845,7 +16834,7 @@
                 <a:solidFill>
                   <a:srgbClr val="6B5B82"/>
                 </a:solidFill>
-                <a:latin typeface="DM Sans"/>
+                <a:latin typeface="Arial"/>
               </a:rPr>
               <a:t>Sources: [1] Nu Q2'26 release (ROE 33%); Nu announcements: Mexico banking authorization (10 Jul 2026, operations as a bank from 6 Aug) and $4.2B plan to 2030; OCC conditional approval of Nubank N.A. (29 Jan 2026); buyback of up to $1.0B (4 Jun 2026); Investor Day 8 Dec 2026. Cost-of-equity figures are to be set with Treasury (ASSUMPTION).</a:t>
             </a:r>
@@ -16880,7 +16869,7 @@
                 <a:solidFill>
                   <a:srgbClr val="820AD1"/>
                 </a:solidFill>
-                <a:latin typeface="DM Sans"/>
+                <a:latin typeface="Arial"/>
               </a:rPr>
               <a:t>1. WHAT IS ON THE TABLE [1]</a:t>
             </a:r>
@@ -16915,7 +16904,7 @@
                 <a:solidFill>
                   <a:srgbClr val="11052C"/>
                 </a:solidFill>
-                <a:latin typeface="Space Grotesk"/>
+                <a:latin typeface="Arial"/>
               </a:rPr>
               <a:t>Four uses of equity</a:t>
             </a:r>
@@ -16950,7 +16939,7 @@
                 <a:solidFill>
                   <a:srgbClr val="3B2A54"/>
                 </a:solidFill>
-                <a:latin typeface="DM Sans"/>
+                <a:latin typeface="Arial"/>
               </a:rPr>
               <a:t>Brazil deepening; Nu Mexico, authorized as a bank in July 2026 and operating as one since August ($4.2B planned to 2030); the US de novo charter, to be capitalized within 12 months of the 29 January 2026 OCC approval; and the buyback of up to $1.0B announced in June 2026.</a:t>
             </a:r>
@@ -16985,7 +16974,7 @@
                 <a:solidFill>
                   <a:srgbClr val="5B21B6"/>
                 </a:solidFill>
-                <a:latin typeface="DM Sans"/>
+                <a:latin typeface="Arial"/>
               </a:rPr>
               <a:t>2. THE YARDSTICK</a:t>
             </a:r>
@@ -17020,7 +17009,7 @@
                 <a:solidFill>
                   <a:srgbClr val="11052C"/>
                 </a:solidFill>
-                <a:latin typeface="Space Grotesk"/>
+                <a:latin typeface="Arial"/>
               </a:rPr>
               <a:t>Return on allocated capital</a:t>
             </a:r>
@@ -17055,7 +17044,7 @@
                 <a:solidFill>
                   <a:srgbClr val="3B2A54"/>
                 </a:solidFill>
-                <a:latin typeface="DM Sans"/>
+                <a:latin typeface="Arial"/>
               </a:rPr>
               <a:t>Rank each use by after-tax return on incremental allocated equity against that market's cost of equity, with capital headroom by entity under a downside case. A use that beats its cost of equity creates value even if it dilutes the 33% group ROE; the buyback is the bar every growth use must clear.</a:t>
             </a:r>
@@ -17090,7 +17079,7 @@
                 <a:solidFill>
                   <a:srgbClr val="0D9488"/>
                 </a:solidFill>
-                <a:latin typeface="DM Sans"/>
+                <a:latin typeface="Arial"/>
               </a:rPr>
               <a:t>3. WHO DECIDES, AND WHEN</a:t>
             </a:r>
@@ -17125,7 +17114,7 @@
                 <a:solidFill>
                   <a:srgbClr val="11052C"/>
                 </a:solidFill>
-                <a:latin typeface="Space Grotesk"/>
+                <a:latin typeface="Arial"/>
               </a:rPr>
               <a:t>Before Investor Day</a:t>
             </a:r>
@@ -17160,7 +17149,7 @@
                 <a:solidFill>
                   <a:srgbClr val="3B2A54"/>
                 </a:solidFill>
-                <a:latin typeface="DM Sans"/>
+                <a:latin typeface="Arial"/>
               </a:rPr>
               <a:t>The CFO recommends the ranking, the CEO decides, the Board approves at this meeting, so the Investor Day narrative (8 Dec 2026) rests on an approved plan. My job: one page per use with the same four lines (return, capital, headroom, risk), and the chair's pre-read at T-9.</a:t>
             </a:r>
@@ -17195,7 +17184,7 @@
                 <a:solidFill>
                   <a:srgbClr val="6B5B82"/>
                 </a:solidFill>
-                <a:latin typeface="DM Sans"/>
+                <a:latin typeface="Arial"/>
               </a:rPr>
               <a:t>12</a:t>
             </a:r>
@@ -17332,7 +17321,7 @@
                           <a:solidFill>
                             <a:srgbClr val="FFFFFF"/>
                           </a:solidFill>
-                          <a:latin typeface="Space Grotesk"/>
+                          <a:latin typeface="Arial"/>
                         </a:rPr>
                         <a:t>Prioritization Approach</a:t>
                       </a:r>
@@ -17367,7 +17356,7 @@
                           <a:solidFill>
                             <a:srgbClr val="FFFFFF"/>
                           </a:solidFill>
-                          <a:latin typeface="Space Grotesk"/>
+                          <a:latin typeface="Arial"/>
                         </a:rPr>
                         <a:t>Meets $25M Cap (30%)</a:t>
                       </a:r>
@@ -17402,7 +17391,7 @@
                           <a:solidFill>
                             <a:srgbClr val="FFFFFF"/>
                           </a:solidFill>
-                          <a:latin typeface="Space Grotesk"/>
+                          <a:latin typeface="Arial"/>
                         </a:rPr>
                         <a:t>Growth Return (25%)</a:t>
                       </a:r>
@@ -17437,7 +17426,7 @@
                           <a:solidFill>
                             <a:srgbClr val="FFFFFF"/>
                           </a:solidFill>
-                          <a:latin typeface="Space Grotesk"/>
+                          <a:latin typeface="Arial"/>
                         </a:rPr>
                         <a:t>GM Ownership (20%)</a:t>
                       </a:r>
@@ -17472,7 +17461,7 @@
                           <a:solidFill>
                             <a:srgbClr val="FFFFFF"/>
                           </a:solidFill>
-                          <a:latin typeface="Space Grotesk"/>
+                          <a:latin typeface="Arial"/>
                         </a:rPr>
                         <a:t>Business Agility (15%)</a:t>
                       </a:r>
@@ -17507,7 +17496,7 @@
                           <a:solidFill>
                             <a:srgbClr val="FFFFFF"/>
                           </a:solidFill>
-                          <a:latin typeface="Space Grotesk"/>
+                          <a:latin typeface="Arial"/>
                         </a:rPr>
                         <a:t>Speed (10%)</a:t>
                       </a:r>
@@ -17542,7 +17531,7 @@
                           <a:solidFill>
                             <a:srgbClr val="FFFFFF"/>
                           </a:solidFill>
-                          <a:latin typeface="Space Grotesk"/>
+                          <a:latin typeface="Arial"/>
                         </a:rPr>
                         <a:t>Weighted Score</a:t>
                       </a:r>
@@ -17579,7 +17568,7 @@
                           <a:solidFill>
                             <a:srgbClr val="11052C"/>
                           </a:solidFill>
-                          <a:latin typeface="DM Sans"/>
+                          <a:latin typeface="Arial"/>
                         </a:rPr>
                         <a:t>1. Equal percentage cut</a:t>
                       </a:r>
@@ -17588,7 +17577,7 @@
                           <a:solidFill>
                             <a:srgbClr val="11052C"/>
                           </a:solidFill>
-                          <a:latin typeface="DM Sans"/>
+                          <a:latin typeface="Arial"/>
                         </a:rPr>
                         <a:t> (every unit gets 42% of its ask)</a:t>
                       </a:r>
@@ -17623,7 +17612,7 @@
                           <a:solidFill>
                             <a:srgbClr val="11052C"/>
                           </a:solidFill>
-                          <a:latin typeface="DM Sans"/>
+                          <a:latin typeface="Arial"/>
                         </a:rPr>
                         <a:t>90</a:t>
                       </a:r>
@@ -17658,7 +17647,7 @@
                           <a:solidFill>
                             <a:srgbClr val="11052C"/>
                           </a:solidFill>
-                          <a:latin typeface="DM Sans"/>
+                          <a:latin typeface="Arial"/>
                         </a:rPr>
                         <a:t>40</a:t>
                       </a:r>
@@ -17693,7 +17682,7 @@
                           <a:solidFill>
                             <a:srgbClr val="11052C"/>
                           </a:solidFill>
-                          <a:latin typeface="DM Sans"/>
+                          <a:latin typeface="Arial"/>
                         </a:rPr>
                         <a:t>30</a:t>
                       </a:r>
@@ -17728,7 +17717,7 @@
                           <a:solidFill>
                             <a:srgbClr val="11052C"/>
                           </a:solidFill>
-                          <a:latin typeface="DM Sans"/>
+                          <a:latin typeface="Arial"/>
                         </a:rPr>
                         <a:t>35</a:t>
                       </a:r>
@@ -17763,7 +17752,7 @@
                           <a:solidFill>
                             <a:srgbClr val="11052C"/>
                           </a:solidFill>
-                          <a:latin typeface="DM Sans"/>
+                          <a:latin typeface="Arial"/>
                         </a:rPr>
                         <a:t>95</a:t>
                       </a:r>
@@ -17798,7 +17787,7 @@
                           <a:solidFill>
                             <a:srgbClr val="11052C"/>
                           </a:solidFill>
-                          <a:latin typeface="DM Sans"/>
+                          <a:latin typeface="Arial"/>
                         </a:rPr>
                         <a:t>57.8 / 100</a:t>
                       </a:r>
@@ -17835,7 +17824,7 @@
                           <a:solidFill>
                             <a:srgbClr val="11052C"/>
                           </a:solidFill>
-                          <a:latin typeface="DM Sans"/>
+                          <a:latin typeface="Arial"/>
                         </a:rPr>
                         <a:t>2. Core markets first</a:t>
                       </a:r>
@@ -17844,7 +17833,7 @@
                           <a:solidFill>
                             <a:srgbClr val="11052C"/>
                           </a:solidFill>
-                          <a:latin typeface="DM Sans"/>
+                          <a:latin typeface="Arial"/>
                         </a:rPr>
                         <a:t> (fund Brazil, Mexico, Colombia; pause new bets)</a:t>
                       </a:r>
@@ -17879,7 +17868,7 @@
                           <a:solidFill>
                             <a:srgbClr val="11052C"/>
                           </a:solidFill>
-                          <a:latin typeface="DM Sans"/>
+                          <a:latin typeface="Arial"/>
                         </a:rPr>
                         <a:t>95</a:t>
                       </a:r>
@@ -17914,7 +17903,7 @@
                           <a:solidFill>
                             <a:srgbClr val="11052C"/>
                           </a:solidFill>
-                          <a:latin typeface="DM Sans"/>
+                          <a:latin typeface="Arial"/>
                         </a:rPr>
                         <a:t>55</a:t>
                       </a:r>
@@ -17949,7 +17938,7 @@
                           <a:solidFill>
                             <a:srgbClr val="11052C"/>
                           </a:solidFill>
-                          <a:latin typeface="DM Sans"/>
+                          <a:latin typeface="Arial"/>
                         </a:rPr>
                         <a:t>45</a:t>
                       </a:r>
@@ -17984,7 +17973,7 @@
                           <a:solidFill>
                             <a:srgbClr val="11052C"/>
                           </a:solidFill>
-                          <a:latin typeface="DM Sans"/>
+                          <a:latin typeface="Arial"/>
                         </a:rPr>
                         <a:t>30</a:t>
                       </a:r>
@@ -18019,7 +18008,7 @@
                           <a:solidFill>
                             <a:srgbClr val="11052C"/>
                           </a:solidFill>
-                          <a:latin typeface="DM Sans"/>
+                          <a:latin typeface="Arial"/>
                         </a:rPr>
                         <a:t>80</a:t>
                       </a:r>
@@ -18054,7 +18043,7 @@
                           <a:solidFill>
                             <a:srgbClr val="11052C"/>
                           </a:solidFill>
-                          <a:latin typeface="DM Sans"/>
+                          <a:latin typeface="Arial"/>
                         </a:rPr>
                         <a:t>63.8 / 100</a:t>
                       </a:r>
@@ -18091,7 +18080,7 @@
                           <a:solidFill>
                             <a:srgbClr val="11052C"/>
                           </a:solidFill>
-                          <a:latin typeface="DM Sans"/>
+                          <a:latin typeface="Arial"/>
                         </a:rPr>
                         <a:t>3. Business-case readiness + staged release</a:t>
                       </a:r>
@@ -18100,7 +18089,7 @@
                           <a:solidFill>
                             <a:srgbClr val="11052C"/>
                           </a:solidFill>
-                          <a:latin typeface="DM Sans"/>
+                          <a:latin typeface="Arial"/>
                         </a:rPr>
                         <a:t> (recommended)</a:t>
                       </a:r>
@@ -18135,7 +18124,7 @@
                           <a:solidFill>
                             <a:srgbClr val="11052C"/>
                           </a:solidFill>
-                          <a:latin typeface="DM Sans"/>
+                          <a:latin typeface="Arial"/>
                         </a:rPr>
                         <a:t>100</a:t>
                       </a:r>
@@ -18170,7 +18159,7 @@
                           <a:solidFill>
                             <a:srgbClr val="11052C"/>
                           </a:solidFill>
-                          <a:latin typeface="DM Sans"/>
+                          <a:latin typeface="Arial"/>
                         </a:rPr>
                         <a:t>95</a:t>
                       </a:r>
@@ -18205,7 +18194,7 @@
                           <a:solidFill>
                             <a:srgbClr val="11052C"/>
                           </a:solidFill>
-                          <a:latin typeface="DM Sans"/>
+                          <a:latin typeface="Arial"/>
                         </a:rPr>
                         <a:t>85</a:t>
                       </a:r>
@@ -18240,7 +18229,7 @@
                           <a:solidFill>
                             <a:srgbClr val="11052C"/>
                           </a:solidFill>
-                          <a:latin typeface="DM Sans"/>
+                          <a:latin typeface="Arial"/>
                         </a:rPr>
                         <a:t>90</a:t>
                       </a:r>
@@ -18275,7 +18264,7 @@
                           <a:solidFill>
                             <a:srgbClr val="11052C"/>
                           </a:solidFill>
-                          <a:latin typeface="DM Sans"/>
+                          <a:latin typeface="Arial"/>
                         </a:rPr>
                         <a:t>75</a:t>
                       </a:r>
@@ -18310,7 +18299,7 @@
                           <a:solidFill>
                             <a:srgbClr val="820AD1"/>
                           </a:solidFill>
-                          <a:latin typeface="DM Sans"/>
+                          <a:latin typeface="Arial"/>
                         </a:rPr>
                         <a:t>91.8 / 100</a:t>
                       </a:r>
@@ -18367,7 +18356,7 @@
                 <a:solidFill>
                   <a:srgbClr val="820AD1"/>
                 </a:solidFill>
-                <a:latin typeface="DM Sans"/>
+                <a:latin typeface="Arial"/>
               </a:rPr>
               <a:t>APPENDIX B // OPTION SCORES AND WEIGHT SENSITIVITY</a:t>
             </a:r>
@@ -18406,7 +18395,7 @@
                 <a:solidFill>
                   <a:srgbClr val="11052C"/>
                 </a:solidFill>
-                <a:latin typeface="Space Grotesk"/>
+                <a:latin typeface="Arial"/>
               </a:rPr>
               <a:t>Option 3 stays first under every +/-10 point change to any single weight</a:t>
             </a:r>
@@ -18441,7 +18430,7 @@
                 <a:solidFill>
                   <a:srgbClr val="6B5B82"/>
                 </a:solidFill>
-                <a:latin typeface="DM Sans"/>
+                <a:latin typeface="Arial"/>
               </a:rPr>
               <a:t>Weighted total = sum of score x weight. Base weights: cap 30%, growth return 25%, GM ownership 20%, agility 15%, speed 10%.</a:t>
             </a:r>
@@ -18476,7 +18465,7 @@
                 <a:solidFill>
                   <a:srgbClr val="11052C"/>
                 </a:solidFill>
-                <a:latin typeface="DM Sans"/>
+                <a:latin typeface="Arial"/>
               </a:rPr>
               <a:t>Sensitivity (my calculation): </a:t>
             </a:r>
@@ -18485,7 +18474,7 @@
                 <a:solidFill>
                   <a:srgbClr val="11052C"/>
                 </a:solidFill>
-                <a:latin typeface="DM Sans"/>
+                <a:latin typeface="Arial"/>
               </a:rPr>
               <a:t>moving any one weight by +/-10 points and rebalancing the others pro rata leaves the order 3 &gt; 2 &gt; 1 unchanged; the smallest gap between option 3 and option 2 across all cases is above 20 points. Scores are judgment (A9).</a:t>
             </a:r>
@@ -18520,7 +18509,7 @@
                 <a:solidFill>
                   <a:srgbClr val="6B5B82"/>
                 </a:solidFill>
-                <a:latin typeface="DM Sans"/>
+                <a:latin typeface="Arial"/>
               </a:rPr>
               <a:t>22</a:t>
             </a:r>
@@ -18771,7 +18760,7 @@
                 <a:solidFill>
                   <a:srgbClr val="820AD1"/>
                 </a:solidFill>
-                <a:latin typeface="DM Sans"/>
+                <a:latin typeface="Arial"/>
               </a:rPr>
               <a:t>03 // WHY THE CAP MATTERS AT NU'S SCALE</a:t>
             </a:r>
@@ -18810,7 +18799,7 @@
                 <a:solidFill>
                   <a:srgbClr val="11052C"/>
                 </a:solidFill>
-                <a:latin typeface="Space Grotesk"/>
+                <a:latin typeface="Arial"/>
               </a:rPr>
               <a:t>The $35M gap is small against a ~$23B revenue base; the precedent and the FY26 efficiency guide are what matter</a:t>
             </a:r>
@@ -18845,7 +18834,7 @@
                 <a:solidFill>
                   <a:srgbClr val="6B5B82"/>
                 </a:solidFill>
-                <a:latin typeface="DM Sans"/>
+                <a:latin typeface="Arial"/>
               </a:rPr>
               <a:t>Sources: [1] Nu Holdings Q2'26 earnings release and 6-K (138.9M customers; cost to serve $1.0; ARPAC $17.1; efficiency ratio 19.5%; FY26 ~20% per the Q2'26 call). Materiality: my calculation on annualized Q2'26 managerial revenue of ~$23.5B.</a:t>
             </a:r>
@@ -18880,7 +18869,7 @@
                 <a:solidFill>
                   <a:srgbClr val="C084FC"/>
                 </a:solidFill>
-                <a:latin typeface="DM Sans"/>
+                <a:latin typeface="Arial"/>
               </a:rPr>
               <a:t>THE GAP</a:t>
             </a:r>
@@ -18919,7 +18908,7 @@
                 <a:solidFill>
                   <a:srgbClr val="FFFFFF"/>
                 </a:solidFill>
-                <a:latin typeface="Space Grotesk"/>
+                <a:latin typeface="Arial"/>
               </a:rPr>
               <a:t>$35M</a:t>
             </a:r>
@@ -18954,7 +18943,7 @@
                 <a:solidFill>
                   <a:srgbClr val="E9D5FF"/>
                 </a:solidFill>
-                <a:latin typeface="DM Sans"/>
+                <a:latin typeface="Arial"/>
               </a:rPr>
               <a:t>$60M of asks vs a $25M cost cap: about 15 bps of annualized revenue, under 1% of ~$4.6B opex</a:t>
             </a:r>
@@ -18989,7 +18978,7 @@
                 <a:solidFill>
                   <a:srgbClr val="820AD1"/>
                 </a:solidFill>
-                <a:latin typeface="Space Grotesk"/>
+                <a:latin typeface="Arial"/>
               </a:rPr>
               <a:t>1. Keep the efficiency ratio near 20% [1]</a:t>
             </a:r>
@@ -19024,7 +19013,7 @@
                 <a:solidFill>
                   <a:srgbClr val="3B2A54"/>
                 </a:solidFill>
-                <a:latin typeface="DM Sans"/>
+                <a:latin typeface="Arial"/>
               </a:rPr>
               <a:t>Q2'26 came in at 19.5% (17.6% in Q1), with international expansion named as one driver. Management expects about 20% for FY26. Unvetted overhead is what moves that number the wrong way.</a:t>
             </a:r>
@@ -19059,7 +19048,7 @@
                 <a:solidFill>
                   <a:srgbClr val="820AD1"/>
                 </a:solidFill>
-                <a:latin typeface="Space Grotesk"/>
+                <a:latin typeface="Arial"/>
               </a:rPr>
               <a:t>2. Protect the cost-to-serve edge [1]</a:t>
             </a:r>
@@ -19094,7 +19083,7 @@
                 <a:solidFill>
                   <a:srgbClr val="3B2A54"/>
                 </a:solidFill>
-                <a:latin typeface="DM Sans"/>
+                <a:latin typeface="Arial"/>
               </a:rPr>
               <a:t>Monthly cost to serve per active customer is $1.0 (Q2'26, up from $0.8 a year earlier) against $17.1 of monthly ARPAC. The margin is wide; it stays wide only if central costs scale slower than customers.</a:t>
             </a:r>
@@ -19129,7 +19118,7 @@
                 <a:solidFill>
                   <a:srgbClr val="820AD1"/>
                 </a:solidFill>
-                <a:latin typeface="Space Grotesk"/>
+                <a:latin typeface="Arial"/>
               </a:rPr>
               <a:t>3. Set the precedent for the first in-house cycle</a:t>
             </a:r>
@@ -19164,7 +19153,7 @@
                 <a:solidFill>
                   <a:srgbClr val="3B2A54"/>
                 </a:solidFill>
-                <a:latin typeface="DM Sans"/>
+                <a:latin typeface="Arial"/>
               </a:rPr>
               <a:t>This is the first budget cycle planned centrally. How the $35M is closed decides whether GMs bring real cases next year or pad their asks. The process is the product.</a:t>
             </a:r>
@@ -19199,7 +19188,7 @@
                 <a:solidFill>
                   <a:srgbClr val="6B5B82"/>
                 </a:solidFill>
-                <a:latin typeface="DM Sans"/>
+                <a:latin typeface="Arial"/>
               </a:rPr>
               <a:t>4</a:t>
             </a:r>
@@ -19450,7 +19439,7 @@
                 <a:solidFill>
                   <a:srgbClr val="820AD1"/>
                 </a:solidFill>
-                <a:latin typeface="DM Sans"/>
+                <a:latin typeface="Arial"/>
               </a:rPr>
               <a:t>04 // DELIVERABLE 1: THE PLANNING PRINCIPLE</a:t>
             </a:r>
@@ -19489,7 +19478,7 @@
                 <a:solidFill>
                   <a:srgbClr val="11052C"/>
                 </a:solidFill>
-                <a:latin typeface="Space Grotesk"/>
+                <a:latin typeface="Arial"/>
               </a:rPr>
               <a:t>Budgets should be underwritten like credit lines: start small, gate on data, raise fast when the cohort proves out</a:t>
             </a:r>
@@ -19524,7 +19513,7 @@
                 <a:solidFill>
                   <a:srgbClr val="6B5B82"/>
                 </a:solidFill>
-                <a:latin typeface="DM Sans"/>
+                <a:latin typeface="Arial"/>
               </a:rPr>
               <a:t>Sources: [1] Nu Holdings Form 20-F (credit underwriting; 'low-and-grow'). [2] Directional only, not load-bearing: multi-year studies of active capital reallocation (e.g. McKinsey, 1,600 US companies) associate it with higher shareholder returns.</a:t>
             </a:r>
@@ -19559,7 +19548,7 @@
                 <a:solidFill>
                   <a:srgbClr val="FFFFFF"/>
                 </a:solidFill>
-                <a:latin typeface="DM Sans"/>
+                <a:latin typeface="Arial"/>
               </a:rPr>
               <a:t>Why this fits Nu: </a:t>
             </a:r>
@@ -19568,7 +19557,7 @@
                 <a:solidFill>
                   <a:srgbClr val="FFFFFF"/>
                 </a:solidFill>
-                <a:latin typeface="DM Sans"/>
+                <a:latin typeface="Arial"/>
               </a:rPr>
               <a:t>in credit, Nu starts customers on small limits and raises them on repayment behavior. Applying the same logic to budgets replaces one annual negotiation with quarterly evidence. It is Nu's own test-and-learn discipline, applied to Nu's own money.</a:t>
             </a:r>
@@ -19603,7 +19592,7 @@
                 <a:solidFill>
                   <a:srgbClr val="820AD1"/>
                 </a:solidFill>
-                <a:latin typeface="DM Sans"/>
+                <a:latin typeface="Arial"/>
               </a:rPr>
               <a:t>1. NU CREDIT UNDERWRITING [1]</a:t>
             </a:r>
@@ -19638,7 +19627,7 @@
                 <a:solidFill>
                   <a:srgbClr val="11052C"/>
                 </a:solidFill>
-                <a:latin typeface="Space Grotesk"/>
+                <a:latin typeface="Arial"/>
               </a:rPr>
               <a:t>Small Tests First</a:t>
             </a:r>
@@ -19673,7 +19662,7 @@
                 <a:solidFill>
                   <a:srgbClr val="3B2A54"/>
                 </a:solidFill>
-                <a:latin typeface="DM Sans"/>
+                <a:latin typeface="Arial"/>
               </a:rPr>
               <a:t>Nu's 20-F describes low-and-grow underwriting: small initial limits, raised as repayment data comes in. Losses stay controlled because exposure grows only behind evidence.</a:t>
             </a:r>
@@ -19708,7 +19697,7 @@
                 <a:solidFill>
                   <a:srgbClr val="5B21B6"/>
                 </a:solidFill>
-                <a:latin typeface="DM Sans"/>
+                <a:latin typeface="Arial"/>
               </a:rPr>
               <a:t>2. WHAT CHANGES FOR THE CFO</a:t>
             </a:r>
@@ -19743,7 +19732,7 @@
                 <a:solidFill>
                   <a:srgbClr val="11052C"/>
                 </a:solidFill>
-                <a:latin typeface="Space Grotesk"/>
+                <a:latin typeface="Arial"/>
               </a:rPr>
               <a:t>Evidence replaces negotiation</a:t>
             </a:r>
@@ -19778,7 +19767,7 @@
                 <a:solidFill>
                   <a:srgbClr val="3B2A54"/>
                 </a:solidFill>
-                <a:latin typeface="DM Sans"/>
+                <a:latin typeface="Arial"/>
               </a:rPr>
               <a:t>Each release decision reads the same four indicators for every unit: activation, 30-day retention, CAC vs plan, unit cost vs plan. Reallocation across units happens every quarter, not once a year.</a:t>
             </a:r>
@@ -19813,7 +19802,7 @@
                 <a:solidFill>
                   <a:srgbClr val="0D9488"/>
                 </a:solidFill>
-                <a:latin typeface="DM Sans"/>
+                <a:latin typeface="Arial"/>
               </a:rPr>
               <a:t>3. WHAT THIS MEANS FOR GMs</a:t>
             </a:r>
@@ -19848,7 +19837,7 @@
                 <a:solidFill>
                   <a:srgbClr val="11052C"/>
                 </a:solidFill>
-                <a:latin typeface="Space Grotesk"/>
+                <a:latin typeface="Arial"/>
               </a:rPr>
               <a:t>Earn Next Stage via Data</a:t>
             </a:r>
@@ -19883,7 +19872,7 @@
                 <a:solidFill>
                   <a:srgbClr val="3B2A54"/>
                 </a:solidFill>
-                <a:latin typeface="DM Sans"/>
+                <a:latin typeface="Arial"/>
               </a:rPr>
               <a:t>GMs stop fighting for one annual cheque. They get a funded Q1 start and a published rule for unlocking the next stage, so the conversation moves from positions to indicators.</a:t>
             </a:r>
@@ -19918,7 +19907,7 @@
                 <a:solidFill>
                   <a:srgbClr val="6B5B82"/>
                 </a:solidFill>
-                <a:latin typeface="DM Sans"/>
+                <a:latin typeface="Arial"/>
               </a:rPr>
               <a:t>5</a:t>
             </a:r>
@@ -20055,7 +20044,7 @@
                           <a:solidFill>
                             <a:srgbClr val="FFFFFF"/>
                           </a:solidFill>
-                          <a:latin typeface="Space Grotesk"/>
+                          <a:latin typeface="Arial"/>
                         </a:rPr>
                         <a:t>Prioritization Approach</a:t>
                       </a:r>
@@ -20090,7 +20079,7 @@
                           <a:solidFill>
                             <a:srgbClr val="FFFFFF"/>
                           </a:solidFill>
-                          <a:latin typeface="Space Grotesk"/>
+                          <a:latin typeface="Arial"/>
                         </a:rPr>
                         <a:t>Meets $25M Cap (30%)</a:t>
                       </a:r>
@@ -20125,7 +20114,7 @@
                           <a:solidFill>
                             <a:srgbClr val="FFFFFF"/>
                           </a:solidFill>
-                          <a:latin typeface="Space Grotesk"/>
+                          <a:latin typeface="Arial"/>
                         </a:rPr>
                         <a:t>Growth Return (25%)</a:t>
                       </a:r>
@@ -20160,7 +20149,7 @@
                           <a:solidFill>
                             <a:srgbClr val="FFFFFF"/>
                           </a:solidFill>
-                          <a:latin typeface="Space Grotesk"/>
+                          <a:latin typeface="Arial"/>
                         </a:rPr>
                         <a:t>GM Ownership (20%)</a:t>
                       </a:r>
@@ -20195,7 +20184,7 @@
                           <a:solidFill>
                             <a:srgbClr val="FFFFFF"/>
                           </a:solidFill>
-                          <a:latin typeface="Space Grotesk"/>
+                          <a:latin typeface="Arial"/>
                         </a:rPr>
                         <a:t>Business Agility (15%)</a:t>
                       </a:r>
@@ -20230,7 +20219,7 @@
                           <a:solidFill>
                             <a:srgbClr val="FFFFFF"/>
                           </a:solidFill>
-                          <a:latin typeface="Space Grotesk"/>
+                          <a:latin typeface="Arial"/>
                         </a:rPr>
                         <a:t>Speed (10%)</a:t>
                       </a:r>
@@ -20265,7 +20254,7 @@
                           <a:solidFill>
                             <a:srgbClr val="FFFFFF"/>
                           </a:solidFill>
-                          <a:latin typeface="Space Grotesk"/>
+                          <a:latin typeface="Arial"/>
                         </a:rPr>
                         <a:t>Weighted Score</a:t>
                       </a:r>
@@ -20302,7 +20291,7 @@
                           <a:solidFill>
                             <a:srgbClr val="11052C"/>
                           </a:solidFill>
-                          <a:latin typeface="DM Sans"/>
+                          <a:latin typeface="Arial"/>
                         </a:rPr>
                         <a:t>1. Equal percentage cut</a:t>
                       </a:r>
@@ -20311,7 +20300,7 @@
                           <a:solidFill>
                             <a:srgbClr val="11052C"/>
                           </a:solidFill>
-                          <a:latin typeface="DM Sans"/>
+                          <a:latin typeface="Arial"/>
                         </a:rPr>
                         <a:t> (every unit gets 42% of its ask)</a:t>
                       </a:r>
@@ -20346,7 +20335,7 @@
                           <a:solidFill>
                             <a:srgbClr val="11052C"/>
                           </a:solidFill>
-                          <a:latin typeface="DM Sans"/>
+                          <a:latin typeface="Arial"/>
                         </a:rPr>
                         <a:t>90</a:t>
                       </a:r>
@@ -20381,7 +20370,7 @@
                           <a:solidFill>
                             <a:srgbClr val="11052C"/>
                           </a:solidFill>
-                          <a:latin typeface="DM Sans"/>
+                          <a:latin typeface="Arial"/>
                         </a:rPr>
                         <a:t>40</a:t>
                       </a:r>
@@ -20416,7 +20405,7 @@
                           <a:solidFill>
                             <a:srgbClr val="11052C"/>
                           </a:solidFill>
-                          <a:latin typeface="DM Sans"/>
+                          <a:latin typeface="Arial"/>
                         </a:rPr>
                         <a:t>30</a:t>
                       </a:r>
@@ -20451,7 +20440,7 @@
                           <a:solidFill>
                             <a:srgbClr val="11052C"/>
                           </a:solidFill>
-                          <a:latin typeface="DM Sans"/>
+                          <a:latin typeface="Arial"/>
                         </a:rPr>
                         <a:t>35</a:t>
                       </a:r>
@@ -20486,7 +20475,7 @@
                           <a:solidFill>
                             <a:srgbClr val="11052C"/>
                           </a:solidFill>
-                          <a:latin typeface="DM Sans"/>
+                          <a:latin typeface="Arial"/>
                         </a:rPr>
                         <a:t>95</a:t>
                       </a:r>
@@ -20521,7 +20510,7 @@
                           <a:solidFill>
                             <a:srgbClr val="11052C"/>
                           </a:solidFill>
-                          <a:latin typeface="DM Sans"/>
+                          <a:latin typeface="Arial"/>
                         </a:rPr>
                         <a:t>57.8 / 100</a:t>
                       </a:r>
@@ -20558,7 +20547,7 @@
                           <a:solidFill>
                             <a:srgbClr val="11052C"/>
                           </a:solidFill>
-                          <a:latin typeface="DM Sans"/>
+                          <a:latin typeface="Arial"/>
                         </a:rPr>
                         <a:t>2. Core markets first</a:t>
                       </a:r>
@@ -20567,7 +20556,7 @@
                           <a:solidFill>
                             <a:srgbClr val="11052C"/>
                           </a:solidFill>
-                          <a:latin typeface="DM Sans"/>
+                          <a:latin typeface="Arial"/>
                         </a:rPr>
                         <a:t> (fund Brazil, Mexico, Colombia; pause new bets)</a:t>
                       </a:r>
@@ -20602,7 +20591,7 @@
                           <a:solidFill>
                             <a:srgbClr val="11052C"/>
                           </a:solidFill>
-                          <a:latin typeface="DM Sans"/>
+                          <a:latin typeface="Arial"/>
                         </a:rPr>
                         <a:t>95</a:t>
                       </a:r>
@@ -20637,7 +20626,7 @@
                           <a:solidFill>
                             <a:srgbClr val="11052C"/>
                           </a:solidFill>
-                          <a:latin typeface="DM Sans"/>
+                          <a:latin typeface="Arial"/>
                         </a:rPr>
                         <a:t>55</a:t>
                       </a:r>
@@ -20672,7 +20661,7 @@
                           <a:solidFill>
                             <a:srgbClr val="11052C"/>
                           </a:solidFill>
-                          <a:latin typeface="DM Sans"/>
+                          <a:latin typeface="Arial"/>
                         </a:rPr>
                         <a:t>45</a:t>
                       </a:r>
@@ -20707,7 +20696,7 @@
                           <a:solidFill>
                             <a:srgbClr val="11052C"/>
                           </a:solidFill>
-                          <a:latin typeface="DM Sans"/>
+                          <a:latin typeface="Arial"/>
                         </a:rPr>
                         <a:t>30</a:t>
                       </a:r>
@@ -20742,7 +20731,7 @@
                           <a:solidFill>
                             <a:srgbClr val="11052C"/>
                           </a:solidFill>
-                          <a:latin typeface="DM Sans"/>
+                          <a:latin typeface="Arial"/>
                         </a:rPr>
                         <a:t>80</a:t>
                       </a:r>
@@ -20777,7 +20766,7 @@
                           <a:solidFill>
                             <a:srgbClr val="11052C"/>
                           </a:solidFill>
-                          <a:latin typeface="DM Sans"/>
+                          <a:latin typeface="Arial"/>
                         </a:rPr>
                         <a:t>63.8 / 100</a:t>
                       </a:r>
@@ -20814,7 +20803,7 @@
                           <a:solidFill>
                             <a:srgbClr val="11052C"/>
                           </a:solidFill>
-                          <a:latin typeface="DM Sans"/>
+                          <a:latin typeface="Arial"/>
                         </a:rPr>
                         <a:t>3. Business-case readiness + staged release</a:t>
                       </a:r>
@@ -20823,7 +20812,7 @@
                           <a:solidFill>
                             <a:srgbClr val="11052C"/>
                           </a:solidFill>
-                          <a:latin typeface="DM Sans"/>
+                          <a:latin typeface="Arial"/>
                         </a:rPr>
                         <a:t> (recommended)</a:t>
                       </a:r>
@@ -20858,7 +20847,7 @@
                           <a:solidFill>
                             <a:srgbClr val="11052C"/>
                           </a:solidFill>
-                          <a:latin typeface="DM Sans"/>
+                          <a:latin typeface="Arial"/>
                         </a:rPr>
                         <a:t>100</a:t>
                       </a:r>
@@ -20893,7 +20882,7 @@
                           <a:solidFill>
                             <a:srgbClr val="11052C"/>
                           </a:solidFill>
-                          <a:latin typeface="DM Sans"/>
+                          <a:latin typeface="Arial"/>
                         </a:rPr>
                         <a:t>95</a:t>
                       </a:r>
@@ -20928,7 +20917,7 @@
                           <a:solidFill>
                             <a:srgbClr val="11052C"/>
                           </a:solidFill>
-                          <a:latin typeface="DM Sans"/>
+                          <a:latin typeface="Arial"/>
                         </a:rPr>
                         <a:t>85</a:t>
                       </a:r>
@@ -20963,7 +20952,7 @@
                           <a:solidFill>
                             <a:srgbClr val="11052C"/>
                           </a:solidFill>
-                          <a:latin typeface="DM Sans"/>
+                          <a:latin typeface="Arial"/>
                         </a:rPr>
                         <a:t>90</a:t>
                       </a:r>
@@ -20998,7 +20987,7 @@
                           <a:solidFill>
                             <a:srgbClr val="11052C"/>
                           </a:solidFill>
-                          <a:latin typeface="DM Sans"/>
+                          <a:latin typeface="Arial"/>
                         </a:rPr>
                         <a:t>75</a:t>
                       </a:r>
@@ -21033,7 +21022,7 @@
                           <a:solidFill>
                             <a:srgbClr val="820AD1"/>
                           </a:solidFill>
-                          <a:latin typeface="DM Sans"/>
+                          <a:latin typeface="Arial"/>
                         </a:rPr>
                         <a:t>91.8 / 100</a:t>
                       </a:r>
@@ -21090,7 +21079,7 @@
                 <a:solidFill>
                   <a:srgbClr val="820AD1"/>
                 </a:solidFill>
-                <a:latin typeface="DM Sans"/>
+                <a:latin typeface="Arial"/>
               </a:rPr>
               <a:t>05 // DELIVERABLE 1: THREE WAYS TO CLOSE $35M</a:t>
             </a:r>
@@ -21129,7 +21118,7 @@
                 <a:solidFill>
                   <a:srgbClr val="11052C"/>
                 </a:solidFill>
-                <a:latin typeface="Space Grotesk"/>
+                <a:latin typeface="Arial"/>
               </a:rPr>
               <a:t>Three ways to close $35M: staged readiness wins on return and ownership; flat cuts win only on speed</a:t>
             </a:r>
@@ -21164,7 +21153,7 @@
                 <a:solidFill>
                   <a:srgbClr val="6B5B82"/>
                 </a:solidFill>
-                <a:latin typeface="DM Sans"/>
+                <a:latin typeface="Arial"/>
               </a:rPr>
               <a:t>Scores 0-100 per criterion; weighted total = sum of score x weight. Re-run with each weight +/-10 points: option 3 stays first in every case.</a:t>
             </a:r>
@@ -21199,7 +21188,7 @@
                 <a:solidFill>
                   <a:srgbClr val="11052C"/>
                 </a:solidFill>
-                <a:latin typeface="DM Sans"/>
+                <a:latin typeface="Arial"/>
               </a:rPr>
               <a:t>How to read it: </a:t>
             </a:r>
@@ -21208,7 +21197,7 @@
                 <a:solidFill>
                   <a:srgbClr val="11052C"/>
                 </a:solidFill>
-                <a:latin typeface="DM Sans"/>
+                <a:latin typeface="Arial"/>
               </a:rPr>
               <a:t>scores and weights are my judgment (assumption A9). The ranking does not change if any weight moves by 10 points. Option 1 loses on return and ownership: across-the-board cuts teach GMs to pad next year's ask and starve launches below viable scale. Option 2 is honest but gives the new bets nothing to earn.</a:t>
             </a:r>
@@ -21243,7 +21232,7 @@
                 <a:solidFill>
                   <a:srgbClr val="6B5B82"/>
                 </a:solidFill>
-                <a:latin typeface="DM Sans"/>
+                <a:latin typeface="Arial"/>
               </a:rPr>
               <a:t>6</a:t>
             </a:r>
@@ -21304,7 +21293,7 @@
                 <a:solidFill>
                   <a:srgbClr val="820AD1"/>
                 </a:solidFill>
-                <a:latin typeface="DM Sans"/>
+                <a:latin typeface="Arial"/>
               </a:rPr>
               <a:t>06 // DELIVERABLE 1: THE $60M BRIDGE</a:t>
             </a:r>
@@ -21343,7 +21332,7 @@
                 <a:solidFill>
                   <a:srgbClr val="11052C"/>
                 </a:solidFill>
-                <a:latin typeface="Space Grotesk"/>
+                <a:latin typeface="Arial"/>
               </a:rPr>
               <a:t>$60M of asks become $25M of funded spend: $8M delivered on the platform, $12M sent back for a case, $15M conditional</a:t>
             </a:r>
@@ -21378,7 +21367,7 @@
                 <a:solidFill>
                   <a:srgbClr val="3B2A54"/>
                 </a:solidFill>
-                <a:latin typeface="DM Sans"/>
+                <a:latin typeface="Arial"/>
               </a:rPr>
               <a:t>No arbitrary cuts: </a:t>
             </a:r>
@@ -21387,7 +21376,7 @@
                 <a:solidFill>
                   <a:srgbClr val="3B2A54"/>
                 </a:solidFill>
-                <a:latin typeface="DM Sans"/>
+                <a:latin typeface="Arial"/>
               </a:rPr>
               <a:t>$8M of country asks are met by reusing the shared global code base at near-zero marginal cost (A5); $12M of early ideas enter a 60-day business-case track with my team; $15M is conditional on H1 profit above plan under rule A6. $25M is funded now in two gates.</a:t>
             </a:r>
@@ -21440,7 +21429,7 @@
                 <a:solidFill>
                   <a:srgbClr val="6B5B82"/>
                 </a:solidFill>
-                <a:latin typeface="DM Sans"/>
+                <a:latin typeface="Arial"/>
               </a:rPr>
               <a:t>7</a:t>
             </a:r>
@@ -21597,7 +21586,7 @@
                 <a:solidFill>
                   <a:srgbClr val="820AD1"/>
                 </a:solidFill>
-                <a:latin typeface="DM Sans"/>
+                <a:latin typeface="Arial"/>
               </a:rPr>
               <a:t>07 // DELIVERABLE 1: THE OPERATING MODEL AND THE RELEASE RULE</a:t>
             </a:r>
@@ -21636,7 +21625,7 @@
                 <a:solidFill>
                   <a:srgbClr val="11052C"/>
                 </a:solidFill>
-                <a:latin typeface="Space Grotesk"/>
+                <a:latin typeface="Arial"/>
               </a:rPr>
               <a:t>Hub-and-spoke: one model and one calendar centrally, finance partners inside each market and vertical</a:t>
             </a:r>
@@ -21671,7 +21660,7 @@
                 <a:solidFill>
                   <a:srgbClr val="6B5B82"/>
                 </a:solidFill>
-                <a:latin typeface="DM Sans"/>
+                <a:latin typeface="Arial"/>
               </a:rPr>
               <a:t>Sources: Nu Q2'26 release (efficiency ratio 19.5%; FY26 guide ~20% per the call). Cycle-time target is mine; the directional benchmark for central planning hubs (Hackett Group) is in the ledger and not load-bearing.</a:t>
             </a:r>
@@ -21706,7 +21695,7 @@
                 <a:solidFill>
                   <a:srgbClr val="820AD1"/>
                 </a:solidFill>
-                <a:latin typeface="DM Sans"/>
+                <a:latin typeface="Arial"/>
               </a:rPr>
               <a:t>WHY HUB-AND-SPOKE WORKS</a:t>
             </a:r>
@@ -21741,7 +21730,7 @@
                 <a:solidFill>
                   <a:srgbClr val="11052C"/>
                 </a:solidFill>
-                <a:latin typeface="Space Grotesk"/>
+                <a:latin typeface="Arial"/>
               </a:rPr>
               <a:t>One source of truth, local speed</a:t>
             </a:r>
@@ -21776,7 +21765,7 @@
                 <a:solidFill>
                   <a:srgbClr val="5B21B6"/>
                 </a:solidFill>
-                <a:latin typeface="DM Sans"/>
+                <a:latin typeface="Arial"/>
               </a:rPr>
               <a:t>HOW THE $25M CAP UNLOCKS</a:t>
             </a:r>
@@ -21811,7 +21800,7 @@
                 <a:solidFill>
                   <a:srgbClr val="11052C"/>
                 </a:solidFill>
-                <a:latin typeface="Space Grotesk"/>
+                <a:latin typeface="Arial"/>
               </a:rPr>
               <a:t>Two gates inside the cap, one valve above it</a:t>
             </a:r>
@@ -21846,7 +21835,7 @@
                 <a:solidFill>
                   <a:srgbClr val="3B2A54"/>
                 </a:solidFill>
-                <a:latin typeface="DM Sans"/>
+                <a:latin typeface="Arial"/>
               </a:rPr>
               <a:t>•</a:t>
             </a:r>
@@ -21881,7 +21870,7 @@
                 <a:solidFill>
                   <a:srgbClr val="3B2A54"/>
                 </a:solidFill>
-                <a:latin typeface="DM Sans"/>
+                <a:latin typeface="Arial"/>
               </a:rPr>
               <a:t>Central planning hub (6-8 people, A10): </a:t>
             </a:r>
@@ -21890,7 +21879,7 @@
                 <a:solidFill>
                   <a:srgbClr val="3B2A54"/>
                 </a:solidFill>
-                <a:latin typeface="DM Sans"/>
+                <a:latin typeface="Arial"/>
               </a:rPr>
               <a:t>takes the annual cycle and the single model in-house from the business units; reads Nu's data platform, not spreadsheets. KPIs: cycle time under 40 days, forecast accuracy, 100% of spend with an approved case.</a:t>
             </a:r>
@@ -21925,7 +21914,7 @@
                 <a:solidFill>
                   <a:srgbClr val="3B2A54"/>
                 </a:solidFill>
-                <a:latin typeface="DM Sans"/>
+                <a:latin typeface="Arial"/>
               </a:rPr>
               <a:t>•</a:t>
             </a:r>
@@ -21960,7 +21949,7 @@
                 <a:solidFill>
                   <a:srgbClr val="3B2A54"/>
                 </a:solidFill>
-                <a:latin typeface="DM Sans"/>
+                <a:latin typeface="Arial"/>
               </a:rPr>
               <a:t>Embedded finance partners: </a:t>
             </a:r>
@@ -21969,7 +21958,7 @@
                 <a:solidFill>
                   <a:srgbClr val="3B2A54"/>
                 </a:solidFill>
-                <a:latin typeface="DM Sans"/>
+                <a:latin typeface="Arial"/>
               </a:rPr>
               <a:t>solid line to the hub, dotted line to the GM; in place by Day 95. They build the cases with the GMs and own the indicator read-outs at each gate.</a:t>
             </a:r>
@@ -22004,7 +21993,7 @@
                 <a:solidFill>
                   <a:srgbClr val="3B2A54"/>
                 </a:solidFill>
-                <a:latin typeface="DM Sans"/>
+                <a:latin typeface="Arial"/>
               </a:rPr>
               <a:t>•</a:t>
             </a:r>
@@ -22039,7 +22028,7 @@
                 <a:solidFill>
                   <a:srgbClr val="3B2A54"/>
                 </a:solidFill>
-                <a:latin typeface="DM Sans"/>
+                <a:latin typeface="Arial"/>
               </a:rPr>
               <a:t>Gate 1, $15M at FY27 start (1 Jan): </a:t>
             </a:r>
@@ -22048,7 +22037,7 @@
                 <a:solidFill>
                   <a:srgbClr val="3B2A54"/>
                 </a:solidFill>
-                <a:latin typeface="DM Sans"/>
+                <a:latin typeface="Arial"/>
               </a:rPr>
               <a:t>released to the vetted cases ($10.5M core markets, $4.5M new bets).</a:t>
             </a:r>
@@ -22083,7 +22072,7 @@
                 <a:solidFill>
                   <a:srgbClr val="3B2A54"/>
                 </a:solidFill>
-                <a:latin typeface="DM Sans"/>
+                <a:latin typeface="Arial"/>
               </a:rPr>
               <a:t>•</a:t>
             </a:r>
@@ -22118,7 +22107,7 @@
                 <a:solidFill>
                   <a:srgbClr val="3B2A54"/>
                 </a:solidFill>
-                <a:latin typeface="DM Sans"/>
+                <a:latin typeface="Arial"/>
               </a:rPr>
               <a:t>Gate 2, $10M at Q1 close (31 Mar): </a:t>
             </a:r>
@@ -22127,7 +22116,7 @@
                 <a:solidFill>
                   <a:srgbClr val="3B2A54"/>
                 </a:solidFill>
-                <a:latin typeface="DM Sans"/>
+                <a:latin typeface="Arial"/>
               </a:rPr>
               <a:t>completes the $25M cap; released to units whose Q1 indicators (activation, 30-day retention, CAC and unit cost vs plan) hold.</a:t>
             </a:r>
@@ -22162,7 +22151,7 @@
                 <a:solidFill>
                   <a:srgbClr val="3B2A54"/>
                 </a:solidFill>
-                <a:latin typeface="DM Sans"/>
+                <a:latin typeface="Arial"/>
               </a:rPr>
               <a:t>•</a:t>
             </a:r>
@@ -22197,7 +22186,7 @@
                 <a:solidFill>
                   <a:srgbClr val="3B2A54"/>
                 </a:solidFill>
-                <a:latin typeface="DM Sans"/>
+                <a:latin typeface="Arial"/>
               </a:rPr>
               <a:t>The A6 valve: </a:t>
             </a:r>
@@ -22206,9 +22195,9 @@
                 <a:solidFill>
                   <a:srgbClr val="3B2A54"/>
                 </a:solidFill>
-                <a:latin typeface="DM Sans"/>
-              </a:rPr>
-              <a:t>up to $15M in H2, only from H1 profit above plan, sized to stay inside the efficiency guide, with CFO and IR sign-off. Not in the base plan; disclosed as upside spend, not a change to guidance.</a:t>
+                <a:latin typeface="Arial"/>
+              </a:rPr>
+              <a:t>up to $15M in H2, only from H1 profit above plan, inside the efficiency guide, with CFO and IR sign-off. Not in the base plan.</a:t>
             </a:r>
           </a:p>
         </p:txBody>
@@ -22241,7 +22230,7 @@
                 <a:solidFill>
                   <a:srgbClr val="6B5B82"/>
                 </a:solidFill>
-                <a:latin typeface="DM Sans"/>
+                <a:latin typeface="Arial"/>
               </a:rPr>
               <a:t>8</a:t>
             </a:r>
@@ -22444,7 +22433,7 @@
                 <a:solidFill>
                   <a:srgbClr val="820AD1"/>
                 </a:solidFill>
-                <a:latin typeface="DM Sans"/>
+                <a:latin typeface="Arial"/>
               </a:rPr>
               <a:t>09 // DELIVERABLE 2: SETTLING THE TWO VIEWS</a:t>
             </a:r>
@@ -22483,7 +22472,7 @@
                 <a:solidFill>
                   <a:srgbClr val="11052C"/>
                 </a:solidFill>
-                <a:latin typeface="Space Grotesk"/>
+                <a:latin typeface="Arial"/>
               </a:rPr>
               <a:t>Core markets and new bets are judged on different indicators, so both executives can sign the FY27 opex lock</a:t>
             </a:r>
@@ -22518,7 +22507,7 @@
                 <a:solidFill>
                   <a:srgbClr val="6B5B82"/>
                 </a:solidFill>
-                <a:latin typeface="DM Sans"/>
+                <a:latin typeface="Arial"/>
               </a:rPr>
               <a:t>Sources: [1] Nu Q2'26 release (ARPAC $17.1; ROE 33%); Q1'26 earnings presentation cohort slide ($30.8 monthly ARPAC at 96 months since origination vs $15.9 total). The horizon split follows the three-horizons framing (Baghai, Coley and White), used here as a frame, not as evidence.</a:t>
             </a:r>
@@ -22553,7 +22542,7 @@
                 <a:solidFill>
                   <a:srgbClr val="FFFFFF"/>
                 </a:solidFill>
-                <a:latin typeface="DM Sans"/>
+                <a:latin typeface="Arial"/>
               </a:rPr>
               <a:t>Why both can sign: </a:t>
             </a:r>
@@ -22562,7 +22551,7 @@
                 <a:solidFill>
                   <a:srgbClr val="FFFFFF"/>
                 </a:solidFill>
-                <a:latin typeface="DM Sans"/>
+                <a:latin typeface="Arial"/>
               </a:rPr>
               <a:t>core markets get 70% of the first release to protect the year; new bets get a protected $4.5M start plus first claim on up to $14M across gate 2 and the A6 valve, if it opens. I write the one-page options memo; the CFO recommends; the CEO decides; the Board chair gets the pre-read. This is opex (A4); equity for Mexico and the US charter is the Board's own decision, next slide but one.</a:t>
             </a:r>
@@ -22597,7 +22586,7 @@
                 <a:solidFill>
                   <a:srgbClr val="820AD1"/>
                 </a:solidFill>
-                <a:latin typeface="DM Sans"/>
+                <a:latin typeface="Arial"/>
               </a:rPr>
               <a:t>HORIZON 1: CORE MARKETS (BRAZIL, MEXICO, COLOMBIA)</a:t>
             </a:r>
@@ -22632,7 +22621,7 @@
                 <a:solidFill>
                   <a:srgbClr val="11052C"/>
                 </a:solidFill>
-                <a:latin typeface="Space Grotesk"/>
+                <a:latin typeface="Arial"/>
               </a:rPr>
               <a:t>70% of the gate-1 release ($10.5M)</a:t>
             </a:r>
@@ -22667,7 +22656,7 @@
                 <a:solidFill>
                   <a:srgbClr val="3B2A54"/>
                 </a:solidFill>
-                <a:latin typeface="DM Sans"/>
+                <a:latin typeface="Arial"/>
               </a:rPr>
               <a:t>Mature cohorts reach ~$31 of monthly ARPAC at eight years vs $17.1 for the group, at 33% ROE (Q2'26). Proven markets get the first, largest release [1].</a:t>
             </a:r>
@@ -22702,7 +22691,7 @@
                 <a:solidFill>
                   <a:srgbClr val="0D9488"/>
                 </a:solidFill>
-                <a:latin typeface="DM Sans"/>
+                <a:latin typeface="Arial"/>
               </a:rPr>
               <a:t>Full year: $16.5M in the cap + up to $5.0M (rule A6)</a:t>
             </a:r>
@@ -22737,7 +22726,7 @@
                 <a:solidFill>
                   <a:srgbClr val="5B21B6"/>
                 </a:solidFill>
-                <a:latin typeface="DM Sans"/>
+                <a:latin typeface="Arial"/>
               </a:rPr>
               <a:t>HORIZON 2 &amp; 3: NEW BETS (NEW VERTICALS AND MARKETS)</a:t>
             </a:r>
@@ -22772,7 +22761,7 @@
                 <a:solidFill>
                   <a:srgbClr val="11052C"/>
                 </a:solidFill>
-                <a:latin typeface="Space Grotesk"/>
+                <a:latin typeface="Arial"/>
               </a:rPr>
               <a:t>30% of the gate-1 release ($4.5M)</a:t>
             </a:r>
@@ -22807,7 +22796,7 @@
                 <a:solidFill>
                   <a:srgbClr val="3B2A54"/>
                 </a:solidFill>
-                <a:latin typeface="DM Sans"/>
+                <a:latin typeface="Arial"/>
               </a:rPr>
               <a:t>A new bet judged on mature-market profit in its first quarter always loses. New bets are graded on activation, retention and unit cost until a cohort can show payback.</a:t>
             </a:r>
@@ -22842,7 +22831,7 @@
                 <a:solidFill>
                   <a:srgbClr val="820AD1"/>
                 </a:solidFill>
-                <a:latin typeface="DM Sans"/>
+                <a:latin typeface="Arial"/>
               </a:rPr>
               <a:t>Full year: $8.5M in the cap + up to $10.0M (rule A6)</a:t>
             </a:r>
@@ -22877,7 +22866,7 @@
                 <a:solidFill>
                   <a:srgbClr val="6B5B82"/>
                 </a:solidFill>
-                <a:latin typeface="DM Sans"/>
+                <a:latin typeface="Arial"/>
               </a:rPr>
               <a:t>10</a:t>
             </a:r>
@@ -23178,7 +23167,7 @@
                 <a:solidFill>
                   <a:srgbClr val="820AD1"/>
                 </a:solidFill>
-                <a:latin typeface="DM Sans"/>
+                <a:latin typeface="Arial"/>
               </a:rPr>
               <a:t>12 // DELIVERABLE 2: THE 28-DAY BOARD RHYTHM</a:t>
             </a:r>
@@ -23217,7 +23206,7 @@
                 <a:solidFill>
                   <a:srgbClr val="11052C"/>
                 </a:solidFill>
-                <a:latin typeface="Space Grotesk"/>
+                <a:latin typeface="Arial"/>
               </a:rPr>
               <a:t>The Board book ships at T-7 with written Q&amp;A, after a T-16 executive lock and a T-10 input freeze</a:t>
             </a:r>
@@ -23252,7 +23241,7 @@
                 <a:solidFill>
                   <a:srgbClr val="6B5B82"/>
                 </a:solidFill>
-                <a:latin typeface="DM Sans"/>
+                <a:latin typeface="Arial"/>
               </a:rPr>
               <a:t>Sources: Nu IR calendar (Investor Day 8 Dec 2026). The T-7 book and written-Q&amp;A practice follows common director guidance (e.g. NACD); the time-split figures often quoted for it are directional and not used here.</a:t>
             </a:r>
@@ -23287,7 +23276,7 @@
                 <a:solidFill>
                   <a:srgbClr val="11052C"/>
                 </a:solidFill>
-                <a:latin typeface="DM Sans"/>
+                <a:latin typeface="Arial"/>
               </a:rPr>
               <a:t>Why this meeting matters more than most: </a:t>
             </a:r>
@@ -23296,7 +23285,7 @@
                 <a:solidFill>
                   <a:srgbClr val="11052C"/>
                 </a:solidFill>
-                <a:latin typeface="DM Sans"/>
+                <a:latin typeface="Arial"/>
               </a:rPr>
               <a:t>it is the last Board before Investor Day (8 Dec 2026). The capital plan approved here is the one the market hears. Statutory governance for the expanding entity set is on slide 14.</a:t>
             </a:r>
@@ -23331,7 +23320,7 @@
                 <a:solidFill>
                   <a:srgbClr val="B91C1C"/>
                 </a:solidFill>
-                <a:latin typeface="DM Sans"/>
+                <a:latin typeface="Arial"/>
               </a:rPr>
               <a:t>WEEK 1 (DAYS 28–21)</a:t>
             </a:r>
@@ -23366,7 +23355,7 @@
                 <a:solidFill>
                   <a:srgbClr val="11052C"/>
                 </a:solidFill>
-                <a:latin typeface="Space Grotesk"/>
+                <a:latin typeface="Arial"/>
               </a:rPr>
               <a:t>Shared Storyboard</a:t>
             </a:r>
@@ -23401,7 +23390,7 @@
                 <a:solidFill>
                   <a:srgbClr val="3B2A54"/>
                 </a:solidFill>
-                <a:latin typeface="DM Sans"/>
+                <a:latin typeface="Arial"/>
               </a:rPr>
               <a:t>I issue the locked outline and standard data tables today, so units stop building rival decks. Owner: me, with the Corporate Secretary.</a:t>
             </a:r>
@@ -23436,7 +23425,7 @@
                 <a:solidFill>
                   <a:srgbClr val="D97706"/>
                 </a:solidFill>
-                <a:latin typeface="DM Sans"/>
+                <a:latin typeface="Arial"/>
               </a:rPr>
               <a:t>WEEK 2 (DAYS 20–14)</a:t>
             </a:r>
@@ -23471,7 +23460,7 @@
                 <a:solidFill>
                   <a:srgbClr val="11052C"/>
                 </a:solidFill>
-                <a:latin typeface="Space Grotesk"/>
+                <a:latin typeface="Arial"/>
               </a:rPr>
               <a:t>Executive Lock</a:t>
             </a:r>
@@ -23506,7 +23495,7 @@
                 <a:solidFill>
                   <a:srgbClr val="3B2A54"/>
                 </a:solidFill>
-                <a:latin typeface="DM Sans"/>
+                <a:latin typeface="Arial"/>
               </a:rPr>
               <a:t>One-to-one pre-alignment at T-21; the capital options memo settles the 70/30 lock with CEO and CFO at T-16.</a:t>
             </a:r>
@@ -23541,7 +23530,7 @@
                 <a:solidFill>
                   <a:srgbClr val="820AD1"/>
                 </a:solidFill>
-                <a:latin typeface="DM Sans"/>
+                <a:latin typeface="Arial"/>
               </a:rPr>
               <a:t>WEEK 3 (DAYS 13–7)</a:t>
             </a:r>
@@ -23576,7 +23565,7 @@
                 <a:solidFill>
                   <a:srgbClr val="11052C"/>
                 </a:solidFill>
-                <a:latin typeface="Space Grotesk"/>
+                <a:latin typeface="Arial"/>
               </a:rPr>
               <a:t>Single-Pen Edit</a:t>
             </a:r>
@@ -23611,7 +23600,7 @@
                 <a:solidFill>
                   <a:srgbClr val="3B2A54"/>
                 </a:solidFill>
-                <a:latin typeface="DM Sans"/>
+                <a:latin typeface="Arial"/>
               </a:rPr>
               <a:t>Inputs freeze at T-10 for single-pen editing; committee chairs pre-briefed at T-9; book on the portal at T-7.</a:t>
             </a:r>
@@ -23646,7 +23635,7 @@
                 <a:solidFill>
                   <a:srgbClr val="0D9488"/>
                 </a:solidFill>
-                <a:latin typeface="DM Sans"/>
+                <a:latin typeface="Arial"/>
               </a:rPr>
               <a:t>WEEK 4 (DAYS 6–0)</a:t>
             </a:r>
@@ -23681,7 +23670,7 @@
                 <a:solidFill>
                   <a:srgbClr val="11052C"/>
                 </a:solidFill>
-                <a:latin typeface="Space Grotesk"/>
+                <a:latin typeface="Arial"/>
               </a:rPr>
               <a:t>Strategy, not read-outs</a:t>
             </a:r>
@@ -23716,7 +23705,7 @@
                 <a:solidFill>
                   <a:srgbClr val="3B2A54"/>
                 </a:solidFill>
-                <a:latin typeface="DM Sans"/>
+                <a:latin typeface="Arial"/>
               </a:rPr>
               <a:t>Directors' data questions answered in writing by T-3, so the live session is spent on the capital plan, not read-outs.</a:t>
             </a:r>
@@ -23751,7 +23740,7 @@
                 <a:solidFill>
                   <a:srgbClr val="6B5B82"/>
                 </a:solidFill>
-                <a:latin typeface="DM Sans"/>
+                <a:latin typeface="Arial"/>
               </a:rPr>
               <a:t>13</a:t>
             </a:r>

</xml_diff>